<commit_message>
fixed regressions and weather
</commit_message>
<xml_diff>
--- a/docs/content/regression/regression_lecture.pptx
+++ b/docs/content/regression/regression_lecture.pptx
@@ -4603,11 +4603,11 @@
             </a:pPr>
             <a:r>
               <a:rPr b="1"/>
-              <a:t>🛑 After this chunk: Activity Parts 1–4</a:t>
-            </a:r>
-            <a:r>
-              <a:rPr/>
-              <a:t> (load, plot, fit, read the summary).</a:t>
+              <a:t>🛑 After this chunk: Activity Parts 1–3</a:t>
+            </a:r>
+            <a:r>
+              <a:rPr/>
+              <a:t> (the study, load, plot, fit, read the summary).</a:t>
             </a:r>
           </a:p>
         </p:txBody>
@@ -4952,7 +4952,7 @@
                 </a:solidFill>
                 <a:latin typeface="Courier"/>
               </a:rPr>
-              <a:t># Scatter plot of area against mass --------------------</a:t>
+              <a:t># Scatter plot of mass against known area --------------</a:t>
             </a:r>
             <a:br/>
             <a:r>
@@ -5035,7 +5035,7 @@
                 </a:solidFill>
                 <a:latin typeface="Courier"/>
               </a:rPr>
-              <a:t> mass_g, </a:t>
+              <a:t> area_cm2, </a:t>
             </a:r>
             <a:r>
               <a:rPr>
@@ -5053,7 +5053,7 @@
                 </a:solidFill>
                 <a:latin typeface="Courier"/>
               </a:rPr>
-              <a:t> area_cm2)) </a:t>
+              <a:t> mass_g)) </a:t>
             </a:r>
             <a:r>
               <a:rPr>
@@ -5242,7 +5242,23 @@
             </a:r>
             <a:r>
               <a:rPr/>
-              <a:t> puts the explanatory variable on x and the response on y, and </a:t>
+              <a:t> puts the variable you </a:t>
+            </a:r>
+            <a:r>
+              <a:rPr b="1"/>
+              <a:t>set</a:t>
+            </a:r>
+            <a:r>
+              <a:rPr/>
+              <a:t> on x and the one you </a:t>
+            </a:r>
+            <a:r>
+              <a:rPr b="1"/>
+              <a:t>measured</a:t>
+            </a:r>
+            <a:r>
+              <a:rPr/>
+              <a:t> on y, and </a:t>
             </a:r>
             <a:r>
               <a:rPr>
@@ -5414,7 +5430,7 @@
                 </a:solidFill>
                 <a:latin typeface="Courier"/>
               </a:rPr>
-              <a:t>paper_lm_model &lt;- </a:t>
+              <a:t>paper_model &lt;- </a:t>
             </a:r>
             <a:r>
               <a:rPr>
@@ -5432,7 +5448,7 @@
                 </a:solidFill>
                 <a:latin typeface="Courier"/>
               </a:rPr>
-              <a:t>(area_cm2 </a:t>
+              <a:t>(mass_g </a:t>
             </a:r>
             <a:r>
               <a:rPr>
@@ -5450,7 +5466,7 @@
                 </a:solidFill>
                 <a:latin typeface="Courier"/>
               </a:rPr>
-              <a:t> mass_g, </a:t>
+              <a:t> area_cm2, </a:t>
             </a:r>
             <a:r>
               <a:rPr>
@@ -5661,11 +5677,11 @@
               <a:rPr>
                 <a:latin typeface="Courier"/>
               </a:rPr>
-              <a:t>area_cm2 ~ mass_g</a:t>
-            </a:r>
-            <a:r>
-              <a:rPr/>
-              <a:t> is “area is predicted by mass.”</a:t>
+              <a:t>mass_g ~ area_cm2</a:t>
+            </a:r>
+            <a:r>
+              <a:rPr/>
+              <a:t> is “mass is predicted by area.”</a:t>
             </a:r>
           </a:p>
           <a:p>
@@ -5683,21 +5699,45 @@
             </a:pPr>
             <a:r>
               <a:rPr sz="2000" b="1"/>
-              <a:t>⚠️ Get the order wrong and R will still answer.</a:t>
+              <a:t>⚠️ Which way round?</a:t>
             </a:r>
             <a:r>
               <a:rPr sz="2000"/>
-              <a:t> </a:t>
+              <a:t> We </a:t>
+            </a:r>
+            <a:r>
+              <a:rPr sz="2000" b="1"/>
+              <a:t>cut</a:t>
+            </a:r>
+            <a:r>
+              <a:rPr sz="2000"/>
+              <a:t> the areas and </a:t>
+            </a:r>
+            <a:r>
+              <a:rPr sz="2000" b="1"/>
+              <a:t>measured</a:t>
+            </a:r>
+            <a:r>
+              <a:rPr sz="2000"/>
+              <a:t> the masses, so </a:t>
+            </a:r>
+            <a:r>
+              <a:rPr sz="2000" b="1"/>
+              <a:t>mass</a:t>
+            </a:r>
+            <a:r>
+              <a:rPr sz="2000"/>
+              <a:t> is the response. </a:t>
             </a:r>
             <a:r>
               <a:rPr sz="2000">
                 <a:latin typeface="Courier"/>
               </a:rPr>
-              <a:t>lm(mass_g ~ area_cm2)</a:t>
+              <a:t>lm(area_cm2 ~ mass_g)</a:t>
             </a:r>
             <a:r>
               <a:rPr sz="2000"/>
-              <a:t> runs fine — it just fits the question you didn’t ask.</a:t>
+              <a:t> runs fine too — it just asks R to treat ten areas we chose on purpose as if they were the noisy measurement.</a:t>
             </a:r>
           </a:p>
         </p:txBody>
@@ -5804,7 +5844,7 @@
                 </a:solidFill>
                 <a:latin typeface="Courier"/>
               </a:rPr>
-              <a:t>(paper_lm_model)</a:t>
+              <a:t>(paper_model)</a:t>
             </a:r>
           </a:p>
           <a:p>
@@ -5817,17 +5857,17 @@
               </a:rPr>
               <a:t>
 Call:
-lm(formula = area_cm2 ~ mass_g, data = paper_df)
+lm(formula = mass_g ~ area_cm2, data = paper_df)
 Residuals:
-    Min      1Q  Median      3Q     Max 
--7.2774 -0.3059 -0.1221  0.2264  8.7592 
+      Min        1Q    Median        3Q       Max 
+-0.066548 -0.001774  0.000907  0.002267  0.056127 
 Coefficients:
-            Estimate Std. Error t value Pr(&gt;|t|)    
-(Intercept)   0.2792     0.1812   1.541    0.126    
-mass_g      130.5234     0.1473 885.964   &lt;2e-16 ***
+              Estimate Std. Error t value Pr(&gt;|t|)    
+(Intercept) -2.058e-03  1.389e-03  -1.481    0.141    
+area_cm2     7.660e-03  8.646e-06 885.964   &lt;2e-16 ***
 ---
 Signif. codes:  0 '***' 0.001 '**' 0.01 '*' 0.05 '.' 0.1 ' ' 1
-Residual standard error: 1.764 on 116 degrees of freedom
+Residual standard error: 0.01351 on 116 degrees of freedom
 Multiple R-squared:  0.9999,    Adjusted R-squared:  0.9999 
 F-statistic: 7.849e+05 on 1 and 116 DF,  p-value: &lt; 2.2e-16</a:t>
             </a:r>
@@ -5869,7 +5909,7 @@
               <a:rPr>
                 <a:latin typeface="Courier"/>
               </a:rPr>
-              <a:t>mass_g</a:t>
+              <a:t>area_cm2</a:t>
             </a:r>
             <a:r>
               <a:rPr/>
@@ -5947,7 +5987,7 @@
               <a:rPr>
                 <a:latin typeface="Courier"/>
               </a:rPr>
-              <a:t>mass_g</a:t>
+              <a:t>area_cm2</a:t>
             </a:r>
             <a:r>
               <a:rPr/>
@@ -6070,9 +6110,9 @@
                     <a:latin typeface="Courier"/>
                   </a:rPr>
                   <a:t>Coefficients:
-            Estimate Std. Error t value Pr(&gt;|t|)
-(Intercept)   0.2792     0.1812   1.541    0.126
-mass_g      130.5234     0.1473 885.964   &lt;2e-16</a:t>
+              Estimate Std. Error t value Pr(&gt;|t|)
+(Intercept) -2.058e-03  1.389e-03  -1.481    0.141
+area_cm2     7.660e-03  8.646e-06 885.964   &lt;2e-16</a:t>
                 </a:r>
               </a:p>
               <a:p>
@@ -6108,7 +6148,7 @@
                 </a:r>
                 <a:r>
                   <a:rPr b="1"/>
-                  <a:t>0.28</a:t>
+                  <a:t>-0.002058</a:t>
                 </a:r>
                 <a:r>
                   <a:rPr/>
@@ -6125,7 +6165,7 @@
                   <a:rPr>
                     <a:latin typeface="Courier"/>
                   </a:rPr>
-                  <a:t>mass_g</a:t>
+                  <a:t>area_cm2</a:t>
                 </a:r>
                 <a:r>
                   <a:rPr/>
@@ -6133,7 +6173,7 @@
                 </a:r>
                 <a:r>
                   <a:rPr b="1"/>
-                  <a:t>130.52</a:t>
+                  <a:t>0.007660</a:t>
                 </a:r>
                 <a:r>
                   <a:rPr/>
@@ -6146,6 +6186,81 @@
                 <a:r>
                   <a:rPr/>
                   <a:t>, the slope</a:t>
+                </a:r>
+              </a:p>
+              <a:p>
+                <a:pPr lvl="0" indent="0" marL="0">
+                  <a:buNone/>
+                </a:pPr>
+                <a:r>
+                  <a:rPr b="1">
+                    <a:latin typeface="Courier"/>
+                  </a:rPr>
+                  <a:t>7.660e-03</a:t>
+                </a:r>
+                <a:r>
+                  <a:rPr b="1"/>
+                  <a:t> means 7.660 × 10⁻³</a:t>
+                </a:r>
+                <a:r>
+                  <a:rPr/>
+                  <a:t> — move the decimal point three places left.</a:t>
+                </a:r>
+              </a:p>
+              <a:p>
+                <a:pPr lvl="0" indent="0" marL="1270000">
+                  <a:buNone/>
+                </a:pPr>
+                <a:r>
+                  <a:rPr sz="2000" b="1"/>
+                  <a:t>Tip</a:t>
+                </a:r>
+              </a:p>
+              <a:p>
+                <a:pPr lvl="0" indent="0" marL="1270000">
+                  <a:buNone/>
+                </a:pPr>
+                <a:r>
+                  <a:rPr sz="2000"/>
+                  <a:t>Prefer plain decimals? </a:t>
+                </a:r>
+                <a:r>
+                  <a:rPr sz="2000">
+                    <a:latin typeface="Courier"/>
+                  </a:rPr>
+                  <a:t>options(scipen = 999)</a:t>
+                </a:r>
+                <a:r>
+                  <a:rPr sz="2000"/>
+                  <a:t> turns scientific notation off and </a:t>
+                </a:r>
+                <a:r>
+                  <a:rPr sz="2000">
+                    <a:latin typeface="Courier"/>
+                  </a:rPr>
+                  <a:t>options(scipen = 0)</a:t>
+                </a:r>
+                <a:r>
+                  <a:rPr sz="2000"/>
+                  <a:t> turns it back on. We leave it on — with it off, </a:t>
+                </a:r>
+                <a:r>
+                  <a:rPr sz="2000" i="1"/>
+                  <a:t>p</a:t>
+                </a:r>
+                <a:r>
+                  <a:rPr sz="2000"/>
+                  <a:t> prints as </a:t>
+                </a:r>
+                <a:r>
+                  <a:rPr sz="2000">
+                    <a:latin typeface="Courier"/>
+                  </a:rPr>
+                  <a:t>&lt;0.0000000000000002</a:t>
+                </a:r>
+                <a:r>
+                  <a:rPr sz="2000"/>
+                  <a:t>.</a:t>
                 </a:r>
               </a:p>
               <a:p>
@@ -6177,7 +6292,7 @@
                               <m:nor/>
                               <m:sty m:val="p"/>
                             </m:rPr>
-                            <m:t>area</m:t>
+                            <m:t>mass</m:t>
                           </m:r>
                         </m:e>
                       </m:acc>
@@ -6188,7 +6303,13 @@
                         <m:t>=</m:t>
                       </m:r>
                       <m:r>
-                        <m:t>0.28</m:t>
+                        <m:rPr>
+                          <m:sty m:val="p"/>
+                        </m:rPr>
+                        <m:t>−</m:t>
+                      </m:r>
+                      <m:r>
+                        <m:t>0.0021</m:t>
                       </m:r>
                       <m:r>
                         <m:rPr>
@@ -6197,7 +6318,7 @@
                         <m:t>+</m:t>
                       </m:r>
                       <m:r>
-                        <m:t>130.52</m:t>
+                        <m:t>0.00766</m:t>
                       </m:r>
                       <m:r>
                         <m:rPr>
@@ -6210,7 +6331,7 @@
                           <m:nor/>
                           <m:sty m:val="p"/>
                         </m:rPr>
-                        <m:t>mass</m:t>
+                        <m:t>area</m:t>
                       </m:r>
                     </m:oMath>
                   </m:oMathPara>
@@ -6253,28 +6374,49 @@
             </a:r>
             <a:r>
               <a:rPr sz="2000" b="1"/>
-              <a:t>1 gram</a:t>
+              <a:t>1 cm²</a:t>
             </a:r>
             <a:r>
               <a:rPr sz="2000"/>
-              <a:t> of this paper is another </a:t>
+              <a:t> of this paper weighs another </a:t>
             </a:r>
             <a:r>
               <a:rPr sz="2000" b="1"/>
-              <a:t>130.5 cm²</a:t>
+              <a:t>0.00766 g</a:t>
             </a:r>
             <a:r>
               <a:rPr sz="2000"/>
-              <a:t> of area.</a:t>
-            </a:r>
-          </a:p>
-          <a:p>
-            <a:pPr lvl="0" indent="0" marL="0">
-              <a:buNone/>
-            </a:pPr>
-            <a:r>
-              <a:rPr/>
-              <a:t>That is the conversion factor we came for.</a:t>
+              <a:t>.</a:t>
+            </a:r>
+          </a:p>
+          <a:p>
+            <a:pPr lvl="0" indent="0" marL="1270000">
+              <a:buNone/>
+            </a:pPr>
+            <a:r>
+              <a:rPr sz="2000" b="1"/>
+              <a:t>Note</a:t>
+            </a:r>
+          </a:p>
+          <a:p>
+            <a:pPr lvl="0" indent="0" marL="1270000">
+              <a:buNone/>
+            </a:pPr>
+            <a:r>
+              <a:rPr sz="2000" b="1"/>
+              <a:t>×10,000 → 76.6 g/m²</a:t>
+            </a:r>
+            <a:r>
+              <a:rPr sz="2000"/>
+              <a:t> — the paper’s </a:t>
+            </a:r>
+            <a:r>
+              <a:rPr sz="2000" b="1"/>
+              <a:t>grammage</a:t>
+            </a:r>
+            <a:r>
+              <a:rPr sz="2000"/>
+              <a:t>, the number on the side of the ream. Copy paper is sold at 75–80 g/m², so the slope is a property you can go and check.</a:t>
             </a:r>
           </a:p>
           <a:p>
@@ -6574,8 +6716,8 @@
               <a:rPr>
                 <a:latin typeface="Courier"/>
               </a:rPr>
-              <a:t>(Intercept)   0.2792   ...   0.126
-mass_g      130.5234   ...  &lt;2e-16</a:t>
+              <a:t>(Intercept) -2.058e-03  ...   0.141
+area_cm2     7.660e-03  ...  &lt;2e-16</a:t>
             </a:r>
           </a:p>
           <a:p>
@@ -6604,7 +6746,7 @@
               <a:rPr>
                 <a:latin typeface="Courier"/>
               </a:rPr>
-              <a:t>mass_g</a:t>
+              <a:t>area_cm2</a:t>
             </a:r>
             <a:r>
               <a:rPr/>
@@ -6629,7 +6771,7 @@
             </a:r>
             <a:r>
               <a:rPr/>
-              <a:t> the slope is 0 → mass tells you nothing about area</a:t>
+              <a:t> the slope is 0 → area tells you nothing about mass</a:t>
             </a:r>
           </a:p>
           <a:p>
@@ -6648,7 +6790,7 @@
             </a:r>
             <a:r>
               <a:rPr/>
-              <a:t>. Mass predicts area.</a:t>
+              <a:t>. Area predicts mass.</a:t>
             </a:r>
           </a:p>
           <a:p>
@@ -6669,7 +6811,7 @@
             </a:r>
             <a:r>
               <a:rPr/>
-              <a:t> = 0.126, so the intercept is </a:t>
+              <a:t> = 0.141, so the intercept is </a:t>
             </a:r>
             <a:r>
               <a:rPr b="1"/>
@@ -6677,7 +6819,7 @@
             </a:r>
             <a:r>
               <a:rPr/>
-              <a:t> distinguishable from 0 — exactly what physics says it should be. A piece of paper with no mass has no area.</a:t>
+              <a:t> distinguishable from 0 — exactly what physics says it should be. A piece of paper with no area has no mass.</a:t>
             </a:r>
           </a:p>
         </p:txBody>
@@ -7091,7 +7233,7 @@
               <a:rPr>
                 <a:latin typeface="Courier"/>
               </a:rPr>
-              <a:t>Residual standard error: 1.764 on 116 degrees of freedom
+              <a:t>Residual standard error: 0.01351 on 116 degrees of freedom
 Multiple R-squared:  0.9999, Adjusted R-squared:  0.9999
 F-statistic: 7.849e+05 on 1 and 116 DF,  p-value: &lt; 2.2e-16</a:t>
             </a:r>
@@ -7104,7 +7246,7 @@
             </a:r>
             <a:r>
               <a:rPr/>
-              <a:t> → mass explains </a:t>
+              <a:t> → area explains </a:t>
             </a:r>
             <a:r>
               <a:rPr b="1"/>
@@ -7112,7 +7254,7 @@
             </a:r>
             <a:r>
               <a:rPr/>
-              <a:t> of the variation in area. That is manufactured paper, not biology.</a:t>
+              <a:t> of the variation in mass. That is manufactured paper, not biology.</a:t>
             </a:r>
           </a:p>
           <a:p>
@@ -7154,11 +7296,11 @@
             <a:pPr lvl="0"/>
             <a:r>
               <a:rPr b="1"/>
-              <a:t>Residual standard error = 1.76 cm²</a:t>
-            </a:r>
-            <a:r>
-              <a:rPr/>
-              <a:t> → a typical miss is about 1.8 cm².</a:t>
+              <a:t>Residual standard error = 0.0135 g</a:t>
+            </a:r>
+            <a:r>
+              <a:rPr/>
+              <a:t> → a typical miss is about 13 mg.</a:t>
             </a:r>
           </a:p>
         </p:txBody>
@@ -7332,7 +7474,7 @@
             </a:pPr>
             <a:r>
               <a:rPr/>
-              <a:t>→ ACTIVITY 11 Parts 1–4 now</a:t>
+              <a:t>→ ACTIVITY 11 Parts 1–3 now</a:t>
             </a:r>
           </a:p>
         </p:txBody>
@@ -7357,7 +7499,7 @@
             </a:pPr>
             <a:r>
               <a:rPr b="1"/>
-              <a:t>🛑 Do Activity Parts 1–4 now</a:t>
+              <a:t>🛑 Do Activity Parts 1–3 now</a:t>
             </a:r>
           </a:p>
           <a:p>
@@ -7372,11 +7514,11 @@
               <a:rPr>
                 <a:latin typeface="Courier"/>
               </a:rPr>
-              <a:t>lm(area_cm2 ~ mass_g)</a:t>
-            </a:r>
-            <a:r>
-              <a:rPr/>
-              <a:t>, and pull the slope, the </a:t>
+              <a:t>lm(mass_g ~ area_cm2)</a:t>
+            </a:r>
+            <a:r>
+              <a:rPr/>
+              <a:t>, and read the slope, the </a:t>
             </a:r>
             <a:r>
               <a:rPr i="1"/>
@@ -7384,7 +7526,7 @@
             </a:r>
             <a:r>
               <a:rPr/>
-              <a:t>-value, and R² </a:t>
+              <a:t>-value and R² </a:t>
             </a:r>
             <a:r>
               <a:rPr b="1"/>
@@ -7392,7 +7534,7 @@
             </a:r>
             <a:r>
               <a:rPr/>
-              <a:t> — writing them in your answer boxes.</a:t>
+              <a:t>.</a:t>
             </a:r>
           </a:p>
         </p:txBody>
@@ -7483,17 +7625,15 @@
             </a:r>
             <a:r>
               <a:rPr/>
-              <a:t>, using </a:t>
-            </a:r>
-            <a:r>
-              <a:rPr>
-                <a:latin typeface="Courier"/>
-              </a:rPr>
-              <a:t>predict()</a:t>
-            </a:r>
-            <a:r>
-              <a:rPr/>
-              <a:t> on one tracing and then on a whole column, and writing the result up.</a:t>
+              <a:t>, converting the whole column of tracings, averaging away the pseudoreplication, and the paired </a:t>
+            </a:r>
+            <a:r>
+              <a:rPr i="1"/>
+              <a:t>t</a:t>
+            </a:r>
+            <a:r>
+              <a:rPr/>
+              <a:t>-tests.</a:t>
             </a:r>
           </a:p>
           <a:p>
@@ -7502,11 +7642,19 @@
             </a:pPr>
             <a:r>
               <a:rPr b="1"/>
-              <a:t>🛑 After this chunk: Activity Parts 5–9</a:t>
-            </a:r>
-            <a:r>
-              <a:rPr/>
-              <a:t> (plot the line, check the residuals, predict, report).</a:t>
+              <a:t>🛑 After this chunk: Activity Parts 4–7</a:t>
+            </a:r>
+            <a:r>
+              <a:rPr/>
+              <a:t> (check the residuals, convert, average, paired </a:t>
+            </a:r>
+            <a:r>
+              <a:rPr i="1"/>
+              <a:t>t</a:t>
+            </a:r>
+            <a:r>
+              <a:rPr/>
+              <a:t>-tests).</a:t>
             </a:r>
           </a:p>
         </p:txBody>
@@ -7671,7 +7819,7 @@
                 </a:solidFill>
                 <a:latin typeface="Courier"/>
               </a:rPr>
-              <a:t> mass_g, </a:t>
+              <a:t> area_cm2, </a:t>
             </a:r>
             <a:r>
               <a:rPr>
@@ -7689,7 +7837,7 @@
                 </a:solidFill>
                 <a:latin typeface="Courier"/>
               </a:rPr>
-              <a:t> area_cm2)) </a:t>
+              <a:t> mass_g)) </a:t>
             </a:r>
             <a:r>
               <a:rPr>
@@ -8116,7 +8264,7 @@
                 </a:solidFill>
                 <a:latin typeface="Courier"/>
               </a:rPr>
-              <a:t> mass_g, </a:t>
+              <a:t> area_cm2, </a:t>
             </a:r>
             <a:r>
               <a:rPr>
@@ -8134,7 +8282,7 @@
                 </a:solidFill>
                 <a:latin typeface="Courier"/>
               </a:rPr>
-              <a:t> area_cm2)) </a:t>
+              <a:t> mass_g)) </a:t>
             </a:r>
             <a:r>
               <a:rPr>
@@ -8308,53 +8456,53 @@
                 </a:solidFill>
                 <a:latin typeface="Courier"/>
               </a:rPr>
+              <a:t>"Paper area (cm²)"</a:t>
+            </a:r>
+            <a:r>
+              <a:rPr>
+                <a:solidFill>
+                  <a:srgbClr val="003B4F"/>
+                </a:solidFill>
+                <a:latin typeface="Courier"/>
+              </a:rPr>
+              <a:t>,</a:t>
+            </a:r>
+            <a:br/>
+            <a:r>
+              <a:rPr>
+                <a:solidFill>
+                  <a:srgbClr val="003B4F"/>
+                </a:solidFill>
+                <a:latin typeface="Courier"/>
+              </a:rPr>
+              <a:t>       </a:t>
+            </a:r>
+            <a:r>
+              <a:rPr>
+                <a:solidFill>
+                  <a:srgbClr val="657422"/>
+                </a:solidFill>
+                <a:latin typeface="Courier"/>
+              </a:rPr>
+              <a:t>y =</a:t>
+            </a:r>
+            <a:r>
+              <a:rPr>
+                <a:solidFill>
+                  <a:srgbClr val="003B4F"/>
+                </a:solidFill>
+                <a:latin typeface="Courier"/>
+              </a:rPr>
+              <a:t> </a:t>
+            </a:r>
+            <a:r>
+              <a:rPr>
+                <a:solidFill>
+                  <a:srgbClr val="20794D"/>
+                </a:solidFill>
+                <a:latin typeface="Courier"/>
+              </a:rPr>
               <a:t>"Paper mass (g)"</a:t>
-            </a:r>
-            <a:r>
-              <a:rPr>
-                <a:solidFill>
-                  <a:srgbClr val="003B4F"/>
-                </a:solidFill>
-                <a:latin typeface="Courier"/>
-              </a:rPr>
-              <a:t>,</a:t>
-            </a:r>
-            <a:br/>
-            <a:r>
-              <a:rPr>
-                <a:solidFill>
-                  <a:srgbClr val="003B4F"/>
-                </a:solidFill>
-                <a:latin typeface="Courier"/>
-              </a:rPr>
-              <a:t>       </a:t>
-            </a:r>
-            <a:r>
-              <a:rPr>
-                <a:solidFill>
-                  <a:srgbClr val="657422"/>
-                </a:solidFill>
-                <a:latin typeface="Courier"/>
-              </a:rPr>
-              <a:t>y =</a:t>
-            </a:r>
-            <a:r>
-              <a:rPr>
-                <a:solidFill>
-                  <a:srgbClr val="003B4F"/>
-                </a:solidFill>
-                <a:latin typeface="Courier"/>
-              </a:rPr>
-              <a:t> </a:t>
-            </a:r>
-            <a:r>
-              <a:rPr>
-                <a:solidFill>
-                  <a:srgbClr val="20794D"/>
-                </a:solidFill>
-                <a:latin typeface="Courier"/>
-              </a:rPr>
-              <a:t>"Paper area (cm²)"</a:t>
             </a:r>
             <a:r>
               <a:rPr>
@@ -8725,7 +8873,7 @@
                 </a:solidFill>
                 <a:latin typeface="Courier"/>
               </a:rPr>
-              <a:t>(paper_lm_model)</a:t>
+              <a:t>(paper_model)</a:t>
             </a:r>
           </a:p>
         </p:txBody>
@@ -9325,7 +9473,7 @@
                 </a:solidFill>
                 <a:latin typeface="Courier"/>
               </a:rPr>
-              <a:t>(paper_lm_model)) </a:t>
+              <a:t>(paper_model)) </a:t>
             </a:r>
             <a:r>
               <a:rPr>
@@ -9503,16 +9651,16 @@
               <a:t># A tibble: 10 × 2
    area_cm2 biggest_miss
       &lt;dbl&gt;        &lt;dbl&gt;
- 1        1         0.35
- 2        4         0.59
- 3       16         0.65
- 4       36         0.96
- 5       64         1.3 
- 6      100         3.09
- 7      225         2   
- 8      400         7.28
- 9      500         7.39
-10      567         8.76</a:t>
+ 1        1         0   
+ 2        4         0   
+ 3       16         0   
+ 4       36         0.01
+ 5       64         0.01
+ 6      100         0.02
+ 7      225         0.02
+ 8      400         0.06
+ 9      500         0.06
+10      567         0.07</a:t>
             </a:r>
           </a:p>
         </p:txBody>
@@ -9667,326 +9815,555 @@
             </a:pPr>
             <a:r>
               <a:rPr/>
-              <a:t>Predict One Tracing</a:t>
+              <a:t>From Tracing Mass to Leaf Area</a:t>
             </a:r>
           </a:p>
         </p:txBody>
       </p:sp>
-      <p:sp>
-        <p:nvSpPr>
-          <p:cNvPr id="3" name="Content Placeholder 2"/>
-          <p:cNvSpPr>
-            <a:spLocks noGrp="1"/>
-          </p:cNvSpPr>
-          <p:nvPr>
-            <p:ph idx="1" sz="half"/>
-          </p:nvPr>
-        </p:nvSpPr>
-        <p:spPr/>
-        <p:txBody>
-          <a:bodyPr/>
-          <a:lstStyle/>
-          <a:p>
-            <a:pPr lvl="0" indent="0">
-              <a:buNone/>
-            </a:pPr>
-            <a:r>
-              <a:rPr>
-                <a:solidFill>
-                  <a:srgbClr val="5E5E5E"/>
-                </a:solidFill>
-                <a:latin typeface="Courier"/>
-              </a:rPr>
-              <a:t># Predict the area of one leaf tracing ----------------</a:t>
-            </a:r>
-            <a:br/>
-            <a:r>
-              <a:rPr>
-                <a:solidFill>
-                  <a:srgbClr val="5E5E5E"/>
-                </a:solidFill>
-                <a:latin typeface="Courier"/>
-              </a:rPr>
-              <a:t># The tracing weighed 0.138 g</a:t>
-            </a:r>
-            <a:br/>
-            <a:r>
-              <a:rPr>
-                <a:solidFill>
-                  <a:srgbClr val="003B4F"/>
-                </a:solidFill>
-                <a:latin typeface="Courier"/>
-              </a:rPr>
-              <a:t>one_tracing &lt;- </a:t>
-            </a:r>
-            <a:r>
-              <a:rPr>
-                <a:solidFill>
-                  <a:srgbClr val="4758AB"/>
-                </a:solidFill>
-                <a:latin typeface="Courier"/>
-              </a:rPr>
-              <a:t>tibble</a:t>
-            </a:r>
-            <a:r>
-              <a:rPr>
-                <a:solidFill>
-                  <a:srgbClr val="003B4F"/>
-                </a:solidFill>
-                <a:latin typeface="Courier"/>
-              </a:rPr>
-              <a:t>(</a:t>
-            </a:r>
-            <a:r>
-              <a:rPr>
-                <a:solidFill>
-                  <a:srgbClr val="657422"/>
-                </a:solidFill>
-                <a:latin typeface="Courier"/>
-              </a:rPr>
-              <a:t>mass_g =</a:t>
-            </a:r>
-            <a:r>
-              <a:rPr>
-                <a:solidFill>
-                  <a:srgbClr val="003B4F"/>
-                </a:solidFill>
-                <a:latin typeface="Courier"/>
-              </a:rPr>
-              <a:t> </a:t>
-            </a:r>
-            <a:r>
-              <a:rPr>
-                <a:solidFill>
-                  <a:srgbClr val="AD0000"/>
-                </a:solidFill>
-                <a:latin typeface="Courier"/>
-              </a:rPr>
-              <a:t>0.138</a:t>
-            </a:r>
-            <a:r>
-              <a:rPr>
-                <a:solidFill>
-                  <a:srgbClr val="003B4F"/>
-                </a:solidFill>
-                <a:latin typeface="Courier"/>
-              </a:rPr>
-              <a:t>)</a:t>
-            </a:r>
-            <a:br/>
-            <a:br/>
-            <a:r>
-              <a:rPr>
-                <a:solidFill>
-                  <a:srgbClr val="4758AB"/>
-                </a:solidFill>
-                <a:latin typeface="Courier"/>
-              </a:rPr>
-              <a:t>predict</a:t>
-            </a:r>
-            <a:r>
-              <a:rPr>
-                <a:solidFill>
-                  <a:srgbClr val="003B4F"/>
-                </a:solidFill>
-                <a:latin typeface="Courier"/>
-              </a:rPr>
-              <a:t>(paper_lm_model, </a:t>
-            </a:r>
-            <a:r>
-              <a:rPr>
-                <a:solidFill>
-                  <a:srgbClr val="657422"/>
-                </a:solidFill>
-                <a:latin typeface="Courier"/>
-              </a:rPr>
-              <a:t>newdata =</a:t>
-            </a:r>
-            <a:r>
-              <a:rPr>
-                <a:solidFill>
-                  <a:srgbClr val="003B4F"/>
-                </a:solidFill>
-                <a:latin typeface="Courier"/>
-              </a:rPr>
-              <a:t> one_tracing)</a:t>
-            </a:r>
-          </a:p>
-          <a:p>
-            <a:pPr lvl="0" indent="0">
-              <a:buNone/>
-            </a:pPr>
-            <a:r>
-              <a:rPr>
-                <a:latin typeface="Courier"/>
-              </a:rPr>
-              <a:t>       1 
-18.29144 </a:t>
-            </a:r>
-          </a:p>
-          <a:p>
-            <a:pPr lvl="0" indent="0" marL="0">
-              <a:buNone/>
-            </a:pPr>
-            <a:r>
-              <a:rPr/>
-              <a:t>An 0.138 g tracing is about </a:t>
-            </a:r>
-            <a:r>
-              <a:rPr b="1"/>
-              <a:t>18.3 cm²</a:t>
-            </a:r>
-            <a:r>
-              <a:rPr/>
-              <a:t> of leaf.</a:t>
-            </a:r>
-          </a:p>
-        </p:txBody>
-      </p:sp>
-      <p:sp>
-        <p:nvSpPr>
-          <p:cNvPr id="4" name="Content Placeholder 3"/>
-          <p:cNvSpPr>
-            <a:spLocks noGrp="1"/>
-          </p:cNvSpPr>
-          <p:nvPr>
-            <p:ph idx="2" sz="half"/>
-          </p:nvPr>
-        </p:nvSpPr>
-        <p:spPr/>
-        <p:txBody>
-          <a:bodyPr/>
-          <a:lstStyle/>
-          <a:p>
-            <a:pPr lvl="0" indent="0" marL="0">
-              <a:buNone/>
-            </a:pPr>
-            <a:r>
-              <a:rPr b="1">
-                <a:latin typeface="Courier"/>
-              </a:rPr>
-              <a:t>predict()</a:t>
-            </a:r>
-            <a:r>
-              <a:rPr b="1"/>
-              <a:t> takes two things:</a:t>
-            </a:r>
-          </a:p>
-          <a:p>
-            <a:pPr lvl="0"/>
-            <a:r>
-              <a:rPr/>
-              <a:t>the </a:t>
-            </a:r>
-            <a:r>
-              <a:rPr b="1"/>
-              <a:t>model</a:t>
-            </a:r>
-            <a:r>
-              <a:rPr/>
-              <a:t> you fitted</a:t>
-            </a:r>
-          </a:p>
-          <a:p>
-            <a:pPr lvl="0"/>
-            <a:r>
-              <a:rPr>
-                <a:latin typeface="Courier"/>
-              </a:rPr>
-              <a:t>newdata =</a:t>
-            </a:r>
-            <a:r>
-              <a:rPr/>
-              <a:t> — a small data frame of the X values you want predictions for</a:t>
-            </a:r>
-          </a:p>
-          <a:p>
-            <a:pPr lvl="0" indent="0" marL="1270000">
-              <a:buNone/>
-            </a:pPr>
-            <a:r>
-              <a:rPr sz="2000" b="1"/>
-              <a:t>Warning</a:t>
-            </a:r>
-          </a:p>
-          <a:p>
-            <a:pPr lvl="0" indent="0" marL="1270000">
-              <a:buNone/>
-            </a:pPr>
-            <a:r>
-              <a:rPr sz="2000" b="1"/>
-              <a:t>⚠️ The column in </a:t>
-            </a:r>
-            <a:r>
-              <a:rPr sz="2000" b="1">
-                <a:latin typeface="Courier"/>
-              </a:rPr>
-              <a:t>newdata</a:t>
-            </a:r>
-            <a:r>
-              <a:rPr sz="2000" b="1"/>
-              <a:t> must have the same name as in the model.</a:t>
-            </a:r>
-            <a:r>
-              <a:rPr sz="2000"/>
-              <a:t> The model was built on </a:t>
-            </a:r>
-            <a:r>
-              <a:rPr sz="2000">
-                <a:latin typeface="Courier"/>
-              </a:rPr>
-              <a:t>mass_g</a:t>
-            </a:r>
-            <a:r>
-              <a:rPr sz="2000"/>
-              <a:t>, so </a:t>
-            </a:r>
-            <a:r>
-              <a:rPr sz="2000">
-                <a:latin typeface="Courier"/>
-              </a:rPr>
-              <a:t>newdata</a:t>
-            </a:r>
-            <a:r>
-              <a:rPr sz="2000"/>
-              <a:t> needs a column called </a:t>
-            </a:r>
-            <a:r>
-              <a:rPr sz="2000">
-                <a:latin typeface="Courier"/>
-              </a:rPr>
-              <a:t>mass_g</a:t>
-            </a:r>
-            <a:r>
-              <a:rPr sz="2000"/>
-              <a:t>. Call it </a:t>
-            </a:r>
-            <a:r>
-              <a:rPr sz="2000">
-                <a:latin typeface="Courier"/>
-              </a:rPr>
-              <a:t>mass</a:t>
-            </a:r>
-            <a:r>
-              <a:rPr sz="2000"/>
-              <a:t> and R stops with </a:t>
-            </a:r>
-            <a:r>
-              <a:rPr sz="2000" i="1"/>
-              <a:t>“object ‘mass_g’ not found.”</a:t>
-            </a:r>
-          </a:p>
-          <a:p>
-            <a:pPr lvl="0" indent="0" marL="0">
-              <a:buNone/>
-            </a:pPr>
-            <a:r>
-              <a:rPr/>
-              <a:t>This beats doing the arithmetic yourself — no copying the slope, nothing to mistype.</a:t>
-            </a:r>
-          </a:p>
-        </p:txBody>
-      </p:sp>
+      <mc:AlternateContent xmlns:mc="http://schemas.openxmlformats.org/markup-compatibility/2006">
+        <mc:Choice xmlns:a14="http://schemas.microsoft.com/office/drawing/2010/main" Requires="a14">
+          <p:sp>
+            <p:nvSpPr>
+              <p:cNvPr id="3" name="Content Placeholder 2"/>
+              <p:cNvSpPr>
+                <a:spLocks noGrp="1"/>
+              </p:cNvSpPr>
+              <p:nvPr>
+                <p:ph idx="1" sz="half"/>
+              </p:nvPr>
+            </p:nvSpPr>
+            <p:spPr/>
+            <p:txBody>
+              <a:bodyPr/>
+              <a:lstStyle/>
+              <a:p>
+                <a:pPr lvl="0" indent="0" marL="0">
+                  <a:buNone/>
+                </a:pPr>
+                <a:r>
+                  <a:rPr/>
+                  <a:t>The model says</a:t>
+                </a:r>
+              </a:p>
+              <a:p>
+                <a:pPr lvl="0" indent="0" marL="0">
+                  <a:buNone/>
+                </a:pPr>
+                <a14:m>
+                  <m:oMathPara xmlns:m="http://schemas.openxmlformats.org/officeDocument/2006/math">
+                    <m:oMathParaPr>
+                      <m:jc m:val="center"/>
+                    </m:oMathParaPr>
+                    <m:oMath>
+                      <m:r>
+                        <m:rPr>
+                          <m:nor/>
+                          <m:sty m:val="p"/>
+                        </m:rPr>
+                        <m:t>mass</m:t>
+                      </m:r>
+                      <m:r>
+                        <m:rPr>
+                          <m:sty m:val="p"/>
+                        </m:rPr>
+                        <m:t>=</m:t>
+                      </m:r>
+                      <m:r>
+                        <m:t>a</m:t>
+                      </m:r>
+                      <m:r>
+                        <m:rPr>
+                          <m:sty m:val="p"/>
+                        </m:rPr>
+                        <m:t>+</m:t>
+                      </m:r>
+                      <m:r>
+                        <m:t>b</m:t>
+                      </m:r>
+                      <m:r>
+                        <m:rPr>
+                          <m:sty m:val="p"/>
+                        </m:rPr>
+                        <m:t>×</m:t>
+                      </m:r>
+                      <m:r>
+                        <m:rPr>
+                          <m:nor/>
+                          <m:sty m:val="p"/>
+                        </m:rPr>
+                        <m:t>area</m:t>
+                      </m:r>
+                    </m:oMath>
+                  </m:oMathPara>
+                </a14:m>
+              </a:p>
+              <a:p>
+                <a:pPr lvl="0" indent="0" marL="0">
+                  <a:buNone/>
+                </a:pPr>
+                <a:r>
+                  <a:rPr/>
+                  <a:t>We have the </a:t>
+                </a:r>
+                <a:r>
+                  <a:rPr b="1"/>
+                  <a:t>mass</a:t>
+                </a:r>
+                <a:r>
+                  <a:rPr/>
+                  <a:t> and want the </a:t>
+                </a:r>
+                <a:r>
+                  <a:rPr b="1"/>
+                  <a:t>area</a:t>
+                </a:r>
+                <a:r>
+                  <a:rPr/>
+                  <a:t>, so rearrange:</a:t>
+                </a:r>
+              </a:p>
+              <a:p>
+                <a:pPr lvl="0" indent="0" marL="0">
+                  <a:buNone/>
+                </a:pPr>
+                <a14:m>
+                  <m:oMathPara xmlns:m="http://schemas.openxmlformats.org/officeDocument/2006/math">
+                    <m:oMathParaPr>
+                      <m:jc m:val="center"/>
+                    </m:oMathParaPr>
+                    <m:oMath>
+                      <m:r>
+                        <m:rPr>
+                          <m:nor/>
+                          <m:sty m:val="p"/>
+                        </m:rPr>
+                        <m:t>area</m:t>
+                      </m:r>
+                      <m:r>
+                        <m:rPr>
+                          <m:sty m:val="p"/>
+                        </m:rPr>
+                        <m:t>=</m:t>
+                      </m:r>
+                      <m:f>
+                        <m:fPr>
+                          <m:type m:val="bar"/>
+                        </m:fPr>
+                        <m:num>
+                          <m:r>
+                            <m:rPr>
+                              <m:nor/>
+                              <m:sty m:val="p"/>
+                            </m:rPr>
+                            <m:t>mass</m:t>
+                          </m:r>
+                          <m:r>
+                            <m:rPr>
+                              <m:sty m:val="p"/>
+                            </m:rPr>
+                            <m:t>−</m:t>
+                          </m:r>
+                          <m:r>
+                            <m:t>a</m:t>
+                          </m:r>
+                        </m:num>
+                        <m:den>
+                          <m:r>
+                            <m:t>b</m:t>
+                          </m:r>
+                        </m:den>
+                      </m:f>
+                    </m:oMath>
+                  </m:oMathPara>
+                </a14:m>
+              </a:p>
+              <a:p>
+                <a:pPr lvl="0" indent="0">
+                  <a:buNone/>
+                </a:pPr>
+                <a:r>
+                  <a:rPr>
+                    <a:solidFill>
+                      <a:srgbClr val="5E5E5E"/>
+                    </a:solidFill>
+                    <a:latin typeface="Courier"/>
+                  </a:rPr>
+                  <a:t># Typed off the summary(), out of sci notation --------</a:t>
+                </a:r>
+                <a:br/>
+                <a:r>
+                  <a:rPr>
+                    <a:solidFill>
+                      <a:srgbClr val="003B4F"/>
+                    </a:solidFill>
+                    <a:latin typeface="Courier"/>
+                  </a:rPr>
+                  <a:t>intercept &lt;- </a:t>
+                </a:r>
+                <a:r>
+                  <a:rPr>
+                    <a:solidFill>
+                      <a:srgbClr val="5E5E5E"/>
+                    </a:solidFill>
+                    <a:latin typeface="Courier"/>
+                  </a:rPr>
+                  <a:t>-</a:t>
+                </a:r>
+                <a:r>
+                  <a:rPr>
+                    <a:solidFill>
+                      <a:srgbClr val="AD0000"/>
+                    </a:solidFill>
+                    <a:latin typeface="Courier"/>
+                  </a:rPr>
+                  <a:t>0.002058</a:t>
+                </a:r>
+                <a:r>
+                  <a:rPr>
+                    <a:solidFill>
+                      <a:srgbClr val="003B4F"/>
+                    </a:solidFill>
+                    <a:latin typeface="Courier"/>
+                  </a:rPr>
+                  <a:t>   </a:t>
+                </a:r>
+                <a:r>
+                  <a:rPr>
+                    <a:solidFill>
+                      <a:srgbClr val="5E5E5E"/>
+                    </a:solidFill>
+                    <a:latin typeface="Courier"/>
+                  </a:rPr>
+                  <a:t># from -2.058e-03</a:t>
+                </a:r>
+                <a:br/>
+                <a:r>
+                  <a:rPr>
+                    <a:solidFill>
+                      <a:srgbClr val="003B4F"/>
+                    </a:solidFill>
+                    <a:latin typeface="Courier"/>
+                  </a:rPr>
+                  <a:t>slope     &lt;-  </a:t>
+                </a:r>
+                <a:r>
+                  <a:rPr>
+                    <a:solidFill>
+                      <a:srgbClr val="AD0000"/>
+                    </a:solidFill>
+                    <a:latin typeface="Courier"/>
+                  </a:rPr>
+                  <a:t>0.007660</a:t>
+                </a:r>
+                <a:r>
+                  <a:rPr>
+                    <a:solidFill>
+                      <a:srgbClr val="003B4F"/>
+                    </a:solidFill>
+                    <a:latin typeface="Courier"/>
+                  </a:rPr>
+                  <a:t>   </a:t>
+                </a:r>
+                <a:r>
+                  <a:rPr>
+                    <a:solidFill>
+                      <a:srgbClr val="5E5E5E"/>
+                    </a:solidFill>
+                    <a:latin typeface="Courier"/>
+                  </a:rPr>
+                  <a:t># from  7.660e-03</a:t>
+                </a:r>
+                <a:br/>
+                <a:br/>
+                <a:r>
+                  <a:rPr>
+                    <a:solidFill>
+                      <a:srgbClr val="5E5E5E"/>
+                    </a:solidFill>
+                    <a:latin typeface="Courier"/>
+                  </a:rPr>
+                  <a:t># 1 m2 = 10000 cm2</a:t>
+                </a:r>
+                <a:br/>
+                <a:r>
+                  <a:rPr>
+                    <a:solidFill>
+                      <a:srgbClr val="003B4F"/>
+                    </a:solidFill>
+                    <a:latin typeface="Courier"/>
+                  </a:rPr>
+                  <a:t>slope </a:t>
+                </a:r>
+                <a:r>
+                  <a:rPr>
+                    <a:solidFill>
+                      <a:srgbClr val="5E5E5E"/>
+                    </a:solidFill>
+                    <a:latin typeface="Courier"/>
+                  </a:rPr>
+                  <a:t>*</a:t>
+                </a:r>
+                <a:r>
+                  <a:rPr>
+                    <a:solidFill>
+                      <a:srgbClr val="003B4F"/>
+                    </a:solidFill>
+                    <a:latin typeface="Courier"/>
+                  </a:rPr>
+                  <a:t> </a:t>
+                </a:r>
+                <a:r>
+                  <a:rPr>
+                    <a:solidFill>
+                      <a:srgbClr val="AD0000"/>
+                    </a:solidFill>
+                    <a:latin typeface="Courier"/>
+                  </a:rPr>
+                  <a:t>10000</a:t>
+                </a:r>
+              </a:p>
+              <a:p>
+                <a:pPr lvl="0" indent="0">
+                  <a:buNone/>
+                </a:pPr>
+                <a:r>
+                  <a:rPr>
+                    <a:latin typeface="Courier"/>
+                  </a:rPr>
+                  <a:t>[1] 76.6</a:t>
+                </a:r>
+              </a:p>
+            </p:txBody>
+          </p:sp>
+        </mc:Choice>
+      </mc:AlternateContent>
+      <mc:AlternateContent xmlns:mc="http://schemas.openxmlformats.org/markup-compatibility/2006">
+        <mc:Choice xmlns:a14="http://schemas.microsoft.com/office/drawing/2010/main" Requires="a14">
+          <p:sp>
+            <p:nvSpPr>
+              <p:cNvPr id="4" name="Content Placeholder 3"/>
+              <p:cNvSpPr>
+                <a:spLocks noGrp="1"/>
+              </p:cNvSpPr>
+              <p:nvPr>
+                <p:ph idx="2" sz="half"/>
+              </p:nvPr>
+            </p:nvSpPr>
+            <p:spPr/>
+            <p:txBody>
+              <a:bodyPr/>
+              <a:lstStyle/>
+              <a:p>
+                <a:pPr lvl="0"/>
+                <a:r>
+                  <a:rPr b="1"/>
+                  <a:t>Type the two numbers in.</a:t>
+                </a:r>
+                <a:r>
+                  <a:rPr/>
+                  <a:t> They are right there in the Coefficients table, and the arithmetic stays in plain sight</a:t>
+                </a:r>
+              </a:p>
+              <a:p>
+                <a:pPr lvl="0"/>
+                <a:r>
+                  <a:rPr/>
+                  <a:t>Rounding to six decimals changes </a:t>
+                </a:r>
+                <a:r>
+                  <a:rPr b="1"/>
+                  <a:t>nothing</a:t>
+                </a:r>
+                <a:r>
+                  <a:rPr/>
+                  <a:t> — same </a:t>
+                </a:r>
+                <a:r>
+                  <a:rPr i="1"/>
+                  <a:t>t</a:t>
+                </a:r>
+                <a:r>
+                  <a:rPr/>
+                  <a:t>, df and </a:t>
+                </a:r>
+                <a:r>
+                  <a:rPr i="1"/>
+                  <a:t>p</a:t>
+                </a:r>
+                <a:r>
+                  <a:rPr/>
+                  <a:t> at the end</a:t>
+                </a:r>
+              </a:p>
+              <a:p>
+                <a:pPr lvl="0"/>
+                <a:r>
+                  <a:rPr/>
+                  <a:t>Or let R hand them to you: </a:t>
+                </a:r>
+                <a:r>
+                  <a:rPr b="1">
+                    <a:latin typeface="Courier"/>
+                  </a:rPr>
+                  <a:t>coef(paper_model)</a:t>
+                </a:r>
+                <a:r>
+                  <a:rPr/>
+                  <a:t>, then </a:t>
+                </a:r>
+                <a:r>
+                  <a:rPr>
+                    <a:latin typeface="Courier"/>
+                  </a:rPr>
+                  <a:t>[1]</a:t>
+                </a:r>
+                <a:r>
+                  <a:rPr/>
+                  <a:t> and </a:t>
+                </a:r>
+                <a:r>
+                  <a:rPr>
+                    <a:latin typeface="Courier"/>
+                  </a:rPr>
+                  <a:t>[2]</a:t>
+                </a:r>
+                <a:r>
+                  <a:rPr/>
+                  <a:t> — and it prints plain decimals</a:t>
+                </a:r>
+              </a:p>
+              <a:p>
+                <a:pPr lvl="0" indent="0" marL="1270000">
+                  <a:buNone/>
+                </a:pPr>
+                <a:r>
+                  <a:rPr sz="2000" b="1"/>
+                  <a:t>Note</a:t>
+                </a:r>
+              </a:p>
+              <a:p>
+                <a:pPr lvl="0" indent="0" marL="1270000">
+                  <a:buNone/>
+                </a:pPr>
+                <a:r>
+                  <a:rPr sz="2000" b="1"/>
+                  <a:t>×10,000 → 76.6 g/m²</a:t>
+                </a:r>
+                <a:r>
+                  <a:rPr sz="2000"/>
+                  <a:t> — the paper’s </a:t>
+                </a:r>
+                <a:r>
+                  <a:rPr sz="2000" b="1"/>
+                  <a:t>grammage</a:t>
+                </a:r>
+                <a:r>
+                  <a:rPr sz="2000"/>
+                  <a:t>, the number on the side of the ream. Copy paper is sold at 75–80 g/m², so the slope is a property you can </a:t>
+                </a:r>
+                <a:r>
+                  <a:rPr sz="2000" b="1"/>
+                  <a:t>check against the label</a:t>
+                </a:r>
+                <a:r>
+                  <a:rPr sz="2000"/>
+                  <a:t>.</a:t>
+                </a:r>
+              </a:p>
+              <a:p>
+                <a:pPr lvl="0" indent="0" marL="0">
+                  <a:buNone/>
+                </a:pPr>
+                <a:r>
+                  <a:rPr/>
+                  <a:t>A tracing weighing 0.138 g is</a:t>
+                </a:r>
+              </a:p>
+              <a:p>
+                <a:pPr lvl="0" indent="0" marL="0">
+                  <a:buNone/>
+                </a:pPr>
+                <a14:m>
+                  <m:oMathPara xmlns:m="http://schemas.openxmlformats.org/officeDocument/2006/math">
+                    <m:oMathParaPr>
+                      <m:jc m:val="center"/>
+                    </m:oMathParaPr>
+                    <m:oMath>
+                      <m:f>
+                        <m:fPr>
+                          <m:type m:val="bar"/>
+                        </m:fPr>
+                        <m:num>
+                          <m:r>
+                            <m:t>0.138</m:t>
+                          </m:r>
+                          <m:r>
+                            <m:rPr>
+                              <m:sty m:val="p"/>
+                            </m:rPr>
+                            <m:t>−</m:t>
+                          </m:r>
+                          <m:r>
+                            <m:rPr>
+                              <m:sty m:val="p"/>
+                            </m:rPr>
+                            <m:t>(</m:t>
+                          </m:r>
+                          <m:r>
+                            <m:rPr>
+                              <m:sty m:val="p"/>
+                            </m:rPr>
+                            <m:t>−</m:t>
+                          </m:r>
+                          <m:r>
+                            <m:t>0.002058</m:t>
+                          </m:r>
+                          <m:r>
+                            <m:rPr>
+                              <m:sty m:val="p"/>
+                            </m:rPr>
+                            <m:t>)</m:t>
+                          </m:r>
+                        </m:num>
+                        <m:den>
+                          <m:r>
+                            <m:t>0.007660</m:t>
+                          </m:r>
+                        </m:den>
+                      </m:f>
+                      <m:r>
+                        <m:rPr>
+                          <m:sty m:val="p"/>
+                        </m:rPr>
+                        <m:t>=</m:t>
+                      </m:r>
+                      <m:r>
+                        <m:t>18.3</m:t>
+                      </m:r>
+                      <m:sSup>
+                        <m:e>
+                          <m:r>
+                            <m:rPr>
+                              <m:nor/>
+                              <m:sty m:val="p"/>
+                            </m:rPr>
+                            <m:t> cm</m:t>
+                          </m:r>
+                        </m:e>
+                        <m:sup>
+                          <m:r>
+                            <m:t>2</m:t>
+                          </m:r>
+                        </m:sup>
+                      </m:sSup>
+                    </m:oMath>
+                  </m:oMathPara>
+                </a14:m>
+              </a:p>
+            </p:txBody>
+          </p:sp>
+        </mc:Choice>
+      </mc:AlternateContent>
     </p:spTree>
   </p:cSld>
 </p:sld>
@@ -10021,9 +10398,12 @@
         </p:nvSpPr>
         <p:spPr>
           <a:xfrm>
-            <a:off x="139485" y="78119"/>
-            <a:ext cx="8229600" cy="607682"/>
+            <a:off x="0" y="0"/>
+            <a:ext cx="9144000" cy="602780"/>
           </a:xfrm>
+          <a:solidFill>
+            <a:srgbClr val="1A1A2E"/>
+          </a:solidFill>
         </p:spPr>
         <p:txBody>
           <a:bodyPr/>
@@ -10034,19 +10414,19 @@
             </a:pPr>
             <a:r>
               <a:rPr/>
-              <a:t>Predict with an Interval</a:t>
+              <a:t>Convert a Whole Column of Tracings</a:t>
             </a:r>
           </a:p>
         </p:txBody>
       </p:sp>
       <p:sp>
         <p:nvSpPr>
-          <p:cNvPr id="3" name="Text Placeholder 2"/>
+          <p:cNvPr id="3" name="Content Placeholder 2"/>
           <p:cNvSpPr>
             <a:spLocks noGrp="1"/>
           </p:cNvSpPr>
           <p:nvPr>
-            <p:ph idx="1" type="body"/>
+            <p:ph idx="1" sz="half"/>
           </p:nvPr>
         </p:nvSpPr>
         <p:spPr/>
@@ -10064,7 +10444,7 @@
                 </a:solidFill>
                 <a:latin typeface="Courier"/>
               </a:rPr>
-              <a:t># Two tracings, with 95% prediction intervals ---------</a:t>
+              <a:t># Load our leaf data ----------------------------------</a:t>
             </a:r>
             <a:br/>
             <a:r>
@@ -10074,7 +10454,17 @@
                 </a:solidFill>
                 <a:latin typeface="Courier"/>
               </a:rPr>
-              <a:t>two_tracings &lt;- </a:t>
+              <a:t>leaf_df &lt;-</a:t>
+            </a:r>
+            <a:br/>
+            <a:r>
+              <a:rPr>
+                <a:solidFill>
+                  <a:srgbClr val="003B4F"/>
+                </a:solidFill>
+                <a:latin typeface="Courier"/>
+              </a:rPr>
+              <a:t>  </a:t>
             </a:r>
             <a:r>
               <a:rPr>
@@ -10083,7 +10473,7 @@
                 </a:solidFill>
                 <a:latin typeface="Courier"/>
               </a:rPr>
-              <a:t>tibble</a:t>
+              <a:t>read_excel</a:t>
             </a:r>
             <a:r>
               <a:rPr>
@@ -10097,11 +10487,11 @@
             <a:r>
               <a:rPr>
                 <a:solidFill>
-                  <a:srgbClr val="657422"/>
-                </a:solidFill>
-                <a:latin typeface="Courier"/>
-              </a:rPr>
-              <a:t>mass_g =</a:t>
+                  <a:srgbClr val="20794D"/>
+                </a:solidFill>
+                <a:latin typeface="Courier"/>
+              </a:rPr>
+              <a:t>"data/2026_09_03_data_sci_leaf_area.xlsx"</a:t>
             </a:r>
             <a:r>
               <a:rPr>
@@ -10110,7 +10500,26 @@
                 </a:solidFill>
                 <a:latin typeface="Courier"/>
               </a:rPr>
-              <a:t> </a:t>
+              <a:t>) </a:t>
+            </a:r>
+            <a:r>
+              <a:rPr>
+                <a:solidFill>
+                  <a:srgbClr val="5E5E5E"/>
+                </a:solidFill>
+                <a:latin typeface="Courier"/>
+              </a:rPr>
+              <a:t>%&gt;%</a:t>
+            </a:r>
+            <a:br/>
+            <a:r>
+              <a:rPr>
+                <a:solidFill>
+                  <a:srgbClr val="003B4F"/>
+                </a:solidFill>
+                <a:latin typeface="Courier"/>
+              </a:rPr>
+              <a:t>  </a:t>
             </a:r>
             <a:r>
               <a:rPr>
@@ -10119,7 +10528,7 @@
                 </a:solidFill>
                 <a:latin typeface="Courier"/>
               </a:rPr>
-              <a:t>c</a:t>
+              <a:t>clean_names</a:t>
             </a:r>
             <a:r>
               <a:rPr>
@@ -10128,54 +10537,56 @@
                 </a:solidFill>
                 <a:latin typeface="Courier"/>
               </a:rPr>
-              <a:t>(</a:t>
-            </a:r>
-            <a:r>
-              <a:rPr>
-                <a:solidFill>
-                  <a:srgbClr val="AD0000"/>
-                </a:solidFill>
-                <a:latin typeface="Courier"/>
-              </a:rPr>
-              <a:t>0.092</a:t>
-            </a:r>
-            <a:r>
-              <a:rPr>
-                <a:solidFill>
-                  <a:srgbClr val="003B4F"/>
-                </a:solidFill>
-                <a:latin typeface="Courier"/>
-              </a:rPr>
-              <a:t>, </a:t>
-            </a:r>
-            <a:r>
-              <a:rPr>
-                <a:solidFill>
-                  <a:srgbClr val="AD0000"/>
-                </a:solidFill>
-                <a:latin typeface="Courier"/>
-              </a:rPr>
-              <a:t>0.138</a:t>
-            </a:r>
-            <a:r>
-              <a:rPr>
-                <a:solidFill>
-                  <a:srgbClr val="003B4F"/>
-                </a:solidFill>
-                <a:latin typeface="Courier"/>
-              </a:rPr>
-              <a:t>))</a:t>
+              <a:t>()</a:t>
             </a:r>
             <a:br/>
             <a:br/>
             <a:r>
               <a:rPr>
                 <a:solidFill>
+                  <a:srgbClr val="5E5E5E"/>
+                </a:solidFill>
+                <a:latin typeface="Courier"/>
+              </a:rPr>
+              <a:t># Every tracing mass becomes an area ------------------</a:t>
+            </a:r>
+            <a:br/>
+            <a:r>
+              <a:rPr>
+                <a:solidFill>
+                  <a:srgbClr val="003B4F"/>
+                </a:solidFill>
+                <a:latin typeface="Courier"/>
+              </a:rPr>
+              <a:t>leaf_df &lt;- leaf_df </a:t>
+            </a:r>
+            <a:r>
+              <a:rPr>
+                <a:solidFill>
+                  <a:srgbClr val="5E5E5E"/>
+                </a:solidFill>
+                <a:latin typeface="Courier"/>
+              </a:rPr>
+              <a:t>%&gt;%</a:t>
+            </a:r>
+            <a:br/>
+            <a:r>
+              <a:rPr>
+                <a:solidFill>
+                  <a:srgbClr val="003B4F"/>
+                </a:solidFill>
+                <a:latin typeface="Courier"/>
+              </a:rPr>
+              <a:t>  </a:t>
+            </a:r>
+            <a:r>
+              <a:rPr>
+                <a:solidFill>
                   <a:srgbClr val="4758AB"/>
                 </a:solidFill>
                 <a:latin typeface="Courier"/>
               </a:rPr>
-              <a:t>predict</a:t>
+              <a:t>mutate</a:t>
             </a:r>
             <a:r>
               <a:rPr>
@@ -10184,7 +10595,7 @@
                 </a:solidFill>
                 <a:latin typeface="Courier"/>
               </a:rPr>
-              <a:t>(paper_lm_model, </a:t>
+              <a:t>(</a:t>
             </a:r>
             <a:r>
               <a:rPr>
@@ -10193,7 +10604,7 @@
                 </a:solidFill>
                 <a:latin typeface="Courier"/>
               </a:rPr>
-              <a:t>newdata =</a:t>
+              <a:t>area_cm2 =</a:t>
             </a:r>
             <a:r>
               <a:rPr>
@@ -10202,16 +10613,16 @@
                 </a:solidFill>
                 <a:latin typeface="Courier"/>
               </a:rPr>
-              <a:t> two_tracings, </a:t>
-            </a:r>
-            <a:r>
-              <a:rPr>
-                <a:solidFill>
-                  <a:srgbClr val="657422"/>
-                </a:solidFill>
-                <a:latin typeface="Courier"/>
-              </a:rPr>
-              <a:t>interval =</a:t>
+              <a:t> (paper_mass_g </a:t>
+            </a:r>
+            <a:r>
+              <a:rPr>
+                <a:solidFill>
+                  <a:srgbClr val="5E5E5E"/>
+                </a:solidFill>
+                <a:latin typeface="Courier"/>
+              </a:rPr>
+              <a:t>-</a:t>
             </a:r>
             <a:r>
               <a:rPr>
@@ -10220,16 +10631,16 @@
                 </a:solidFill>
                 <a:latin typeface="Courier"/>
               </a:rPr>
-              <a:t> </a:t>
-            </a:r>
-            <a:r>
-              <a:rPr>
-                <a:solidFill>
-                  <a:srgbClr val="20794D"/>
-                </a:solidFill>
-                <a:latin typeface="Courier"/>
-              </a:rPr>
-              <a:t>"prediction"</a:t>
+              <a:t> intercept) </a:t>
+            </a:r>
+            <a:r>
+              <a:rPr>
+                <a:solidFill>
+                  <a:srgbClr val="5E5E5E"/>
+                </a:solidFill>
+                <a:latin typeface="Courier"/>
+              </a:rPr>
+              <a:t>/</a:t>
             </a:r>
             <a:r>
               <a:rPr>
@@ -10238,7 +10649,55 @@
                 </a:solidFill>
                 <a:latin typeface="Courier"/>
               </a:rPr>
-              <a:t>)</a:t>
+              <a:t> slope)</a:t>
+            </a:r>
+            <a:br/>
+            <a:br/>
+            <a:r>
+              <a:rPr>
+                <a:solidFill>
+                  <a:srgbClr val="003B4F"/>
+                </a:solidFill>
+                <a:latin typeface="Courier"/>
+              </a:rPr>
+              <a:t>leaf_df </a:t>
+            </a:r>
+            <a:r>
+              <a:rPr>
+                <a:solidFill>
+                  <a:srgbClr val="5E5E5E"/>
+                </a:solidFill>
+                <a:latin typeface="Courier"/>
+              </a:rPr>
+              <a:t>%&gt;%</a:t>
+            </a:r>
+            <a:br/>
+            <a:r>
+              <a:rPr>
+                <a:solidFill>
+                  <a:srgbClr val="003B4F"/>
+                </a:solidFill>
+                <a:latin typeface="Courier"/>
+              </a:rPr>
+              <a:t>  </a:t>
+            </a:r>
+            <a:r>
+              <a:rPr>
+                <a:solidFill>
+                  <a:srgbClr val="4758AB"/>
+                </a:solidFill>
+                <a:latin typeface="Courier"/>
+              </a:rPr>
+              <a:t>select</a:t>
+            </a:r>
+            <a:r>
+              <a:rPr>
+                <a:solidFill>
+                  <a:srgbClr val="003B4F"/>
+                </a:solidFill>
+                <a:latin typeface="Courier"/>
+              </a:rPr>
+              <a:t>(teams, shade, mass_g, paper_mass_g, area_cm2)</a:t>
             </a:r>
           </a:p>
           <a:p>
@@ -10249,46 +10708,32 @@
               <a:rPr>
                 <a:latin typeface="Courier"/>
               </a:rPr>
-              <a:t>       fit       lwr      upr
-1 12.28736  8.777018 15.79771
-2 18.29144 14.781578 21.80131</a:t>
-            </a:r>
-          </a:p>
-          <a:p>
-            <a:pPr lvl="0" indent="0" marL="0">
-              <a:buNone/>
-            </a:pPr>
-            <a:r>
-              <a:rPr/>
-              <a:t>The 0.138 g tracing is </a:t>
-            </a:r>
-            <a:r>
-              <a:rPr b="1"/>
-              <a:t>18.3 cm²</a:t>
-            </a:r>
-            <a:r>
-              <a:rPr/>
-              <a:t>, somewhere between about </a:t>
-            </a:r>
-            <a:r>
-              <a:rPr b="1"/>
-              <a:t>14.8 and 21.8 cm²</a:t>
-            </a:r>
-            <a:r>
-              <a:rPr/>
-              <a:t>.</a:t>
+              <a:t># A tibble: 53 × 5
+   teams shade mass_g paper_mass_g area_cm2
+   &lt;chr&gt; &lt;chr&gt;  &lt;dbl&gt;        &lt;dbl&gt;    &lt;dbl&gt;
+ 1 12345 sunny   0.4          0.21     27.7
+ 2 12345 sunny   0.48         0.21     27.7
+ 3 12345 sunny   0.34         0.21     27.7
+ 4 12345 sunny   0.65         0.24     31.6
+ 5 12345 sunny   0.27         0.15     19.9
+ 6 12345 sunny   0.43         0.34     44.7
+ 7 12345 shady   0.39         0.29     38.1
+ 8 12345 shady   0.45         0.25     32.9
+ 9 12345 shady   0.6          0.23     30.3
+10 12345 shady   0.57         0.28     36.8
+# ℹ 43 more rows</a:t>
             </a:r>
           </a:p>
         </p:txBody>
       </p:sp>
       <p:sp>
         <p:nvSpPr>
-          <p:cNvPr id="5" name="Text Placeholder 4"/>
+          <p:cNvPr id="4" name="Content Placeholder 3"/>
           <p:cNvSpPr>
             <a:spLocks noGrp="1"/>
           </p:cNvSpPr>
           <p:nvPr>
-            <p:ph idx="3" sz="quarter" type="body"/>
+            <p:ph idx="2" sz="half"/>
           </p:nvPr>
         </p:nvSpPr>
         <p:spPr/>
@@ -10300,294 +10745,78 @@
               <a:buNone/>
             </a:pPr>
             <a:r>
-              <a:rPr>
-                <a:latin typeface="Courier"/>
-              </a:rPr>
-              <a:t>interval = "prediction"</a:t>
-            </a:r>
-            <a:r>
-              <a:rPr/>
-              <a:t> adds two columns:</a:t>
+              <a:rPr b="1"/>
+              <a:t>This is the payoff.</a:t>
+            </a:r>
+            <a:r>
+              <a:rPr/>
+              <a:t> </a:t>
+            </a:r>
+            <a:r>
+              <a:rPr>
+                <a:latin typeface="Courier"/>
+              </a:rPr>
+              <a:t>paper_mass_g</a:t>
+            </a:r>
+            <a:r>
+              <a:rPr/>
+              <a:t> was the mass of each leaf’s tracing — now every leaf has an </a:t>
+            </a:r>
+            <a:r>
+              <a:rPr b="1">
+                <a:latin typeface="Courier"/>
+              </a:rPr>
+              <a:t>area_cm2</a:t>
+            </a:r>
+            <a:r>
+              <a:rPr/>
+              <a:t>.</a:t>
             </a:r>
           </a:p>
           <a:p>
             <a:pPr lvl="0"/>
             <a:r>
-              <a:rPr>
-                <a:latin typeface="Courier"/>
-              </a:rPr>
-              <a:t>fit</a:t>
-            </a:r>
-            <a:r>
-              <a:rPr/>
-              <a:t> — the prediction</a:t>
+              <a:rPr/>
+              <a:t>One line of arithmetic, all 53 rows at once</a:t>
             </a:r>
           </a:p>
           <a:p>
             <a:pPr lvl="0"/>
             <a:r>
-              <a:rPr>
-                <a:latin typeface="Courier"/>
-              </a:rPr>
-              <a:t>lwr</a:t>
-            </a:r>
-            <a:r>
-              <a:rPr/>
-              <a:t> and </a:t>
-            </a:r>
-            <a:r>
-              <a:rPr>
-                <a:latin typeface="Courier"/>
-              </a:rPr>
-              <a:t>upr</a:t>
-            </a:r>
-            <a:r>
-              <a:rPr/>
-              <a:t> — the 95% range</a:t>
-            </a:r>
-          </a:p>
-          <a:p>
-            <a:pPr lvl="0" indent="0" marL="0">
-              <a:buNone/>
-            </a:pPr>
-            <a:r>
-              <a:rPr b="1"/>
-              <a:t>Two kinds of interval:</a:t>
-            </a:r>
-          </a:p>
-        </p:txBody>
-      </p:sp>
-      <p:graphicFrame>
-        <p:nvGraphicFramePr>
-          <p:cNvPr id="6" name="Content Placeholder 5"/>
-          <p:cNvGraphicFramePr>
-            <a:graphicFrameLocks noGrp="1"/>
-          </p:cNvGraphicFramePr>
-          <p:nvPr>
-            <p:ph idx="1"/>
-          </p:nvPr>
-        </p:nvGraphicFramePr>
-        <p:xfrm>
-          <a:off x="4749800" y="1295400"/>
-          <a:ext cx="4038600" cy="3276600"/>
-        </p:xfrm>
-        <a:graphic>
-          <a:graphicData uri="http://schemas.openxmlformats.org/drawingml/2006/table">
-            <a:tbl>
-              <a:tblPr firstRow="1" bandRow="1">
-                <a:tableStyleId>{5C22544A-7EE6-4342-B048-85BDC9FD1C3A}</a:tableStyleId>
-              </a:tblPr>
-              <a:tblGrid>
-                <a:gridCol w="1181100"/>
-                <a:gridCol w="1854200"/>
-                <a:gridCol w="1016000"/>
-              </a:tblGrid>
-              <a:tr h="0">
-                <a:tc>
-                  <a:txBody>
-                    <a:bodyPr/>
-                    <a:lstStyle/>
-                    <a:p>
-                      <a:pPr lvl="0" indent="0" marL="0">
-                        <a:buNone/>
-                      </a:pPr>
-                      <a:r>
-                        <a:rPr>
-                          <a:latin typeface="Courier"/>
-                        </a:rPr>
-                        <a:t>interval =</a:t>
-                      </a:r>
-                    </a:p>
-                  </a:txBody>
-                  <a:tcPr/>
-                </a:tc>
-                <a:tc>
-                  <a:txBody>
-                    <a:bodyPr/>
-                    <a:lstStyle/>
-                    <a:p>
-                      <a:pPr lvl="0" indent="0" marL="0">
-                        <a:buNone/>
-                      </a:pPr>
-                      <a:r>
-                        <a:rPr/>
-                        <a:t>Range for</a:t>
-                      </a:r>
-                    </a:p>
-                  </a:txBody>
-                  <a:tcPr/>
-                </a:tc>
-                <a:tc>
-                  <a:txBody>
-                    <a:bodyPr/>
-                    <a:lstStyle/>
-                    <a:p>
-                      <a:pPr lvl="0" indent="0" marL="0">
-                        <a:buNone/>
-                      </a:pPr>
-                      <a:r>
-                        <a:rPr/>
-                        <a:t>Width</a:t>
-                      </a:r>
-                    </a:p>
-                  </a:txBody>
-                  <a:tcPr/>
-                </a:tc>
-              </a:tr>
-              <a:tr h="0">
-                <a:tc>
-                  <a:txBody>
-                    <a:bodyPr/>
-                    <a:lstStyle/>
-                    <a:p>
-                      <a:pPr lvl="0" indent="0" marL="0">
-                        <a:buNone/>
-                      </a:pPr>
-                      <a:r>
-                        <a:rPr>
-                          <a:latin typeface="Courier"/>
-                        </a:rPr>
-                        <a:t>"confidence"</a:t>
-                      </a:r>
-                    </a:p>
-                  </a:txBody>
-                </a:tc>
-                <a:tc>
-                  <a:txBody>
-                    <a:bodyPr/>
-                    <a:lstStyle/>
-                    <a:p>
-                      <a:pPr lvl="0" indent="0" marL="0">
-                        <a:buNone/>
-                      </a:pPr>
-                      <a:r>
-                        <a:rPr/>
-                        <a:t>the </a:t>
-                      </a:r>
-                      <a:r>
-                        <a:rPr b="1"/>
-                        <a:t>average</a:t>
-                      </a:r>
-                      <a:r>
-                        <a:rPr/>
-                        <a:t> area of all tracings this heavy</a:t>
-                      </a:r>
-                    </a:p>
-                  </a:txBody>
-                </a:tc>
-                <a:tc>
-                  <a:txBody>
-                    <a:bodyPr/>
-                    <a:lstStyle/>
-                    <a:p>
-                      <a:pPr lvl="0" indent="0" marL="0">
-                        <a:buNone/>
-                      </a:pPr>
-                      <a:r>
-                        <a:rPr/>
-                        <a:t>narrower</a:t>
-                      </a:r>
-                    </a:p>
-                  </a:txBody>
-                </a:tc>
-              </a:tr>
-              <a:tr h="0">
-                <a:tc>
-                  <a:txBody>
-                    <a:bodyPr/>
-                    <a:lstStyle/>
-                    <a:p>
-                      <a:pPr lvl="0" indent="0" marL="0">
-                        <a:buNone/>
-                      </a:pPr>
-                      <a:r>
-                        <a:rPr>
-                          <a:latin typeface="Courier"/>
-                        </a:rPr>
-                        <a:t>"prediction"</a:t>
-                      </a:r>
-                    </a:p>
-                  </a:txBody>
-                </a:tc>
-                <a:tc>
-                  <a:txBody>
-                    <a:bodyPr/>
-                    <a:lstStyle/>
-                    <a:p>
-                      <a:pPr lvl="0" indent="0" marL="0">
-                        <a:buNone/>
-                      </a:pPr>
-                      <a:r>
-                        <a:rPr b="1"/>
-                        <a:t>one particular</a:t>
-                      </a:r>
-                      <a:r>
-                        <a:rPr/>
-                        <a:t> tracing</a:t>
-                      </a:r>
-                    </a:p>
-                  </a:txBody>
-                </a:tc>
-                <a:tc>
-                  <a:txBody>
-                    <a:bodyPr/>
-                    <a:lstStyle/>
-                    <a:p>
-                      <a:pPr lvl="0" indent="0" marL="0">
-                        <a:buNone/>
-                      </a:pPr>
-                      <a:r>
-                        <a:rPr/>
-                        <a:t>wider</a:t>
-                      </a:r>
-                    </a:p>
-                  </a:txBody>
-                </a:tc>
-              </a:tr>
-            </a:tbl>
-          </a:graphicData>
-        </a:graphic>
-      </p:graphicFrame>
-      <p:sp>
-        <p:nvSpPr>
-          <p:cNvPr id="6" name="Content Placeholder 5"/>
-          <p:cNvSpPr>
-            <a:spLocks noGrp="1"/>
-          </p:cNvSpPr>
-          <p:nvPr>
-            <p:ph idx="4" sz="quarter"/>
-          </p:nvPr>
-        </p:nvSpPr>
-        <p:spPr/>
-        <p:txBody>
-          <a:bodyPr/>
-          <a:lstStyle/>
-          <a:p>
-            <a:pPr lvl="0" indent="0" marL="0">
-              <a:buNone/>
-            </a:pPr>
-            <a:r>
-              <a:rPr/>
-              <a:t>For a single real leaf, use </a:t>
-            </a:r>
-            <a:r>
-              <a:rPr b="1">
-                <a:latin typeface="Courier"/>
-              </a:rPr>
-              <a:t>"prediction"</a:t>
-            </a:r>
-            <a:r>
-              <a:rPr/>
-              <a:t>.</a:t>
-            </a:r>
-          </a:p>
-          <a:p>
-            <a:pPr lvl="0" indent="0" marL="0">
-              <a:buNone/>
-            </a:pPr>
-            <a:r>
-              <a:rPr/>
-              <a:t>📖 W&amp;S §17.2 pp. 548–550</a:t>
+              <a:rPr/>
+              <a:t>No new function to learn</a:t>
+            </a:r>
+          </a:p>
+          <a:p>
+            <a:pPr lvl="0" indent="0" marL="1270000">
+              <a:buNone/>
+            </a:pPr>
+            <a:r>
+              <a:rPr sz="2000" b="1"/>
+              <a:t>Note</a:t>
+            </a:r>
+          </a:p>
+          <a:p>
+            <a:pPr lvl="0" indent="0" marL="1270000">
+              <a:buNone/>
+            </a:pPr>
+            <a:r>
+              <a:rPr sz="2000" b="1"/>
+              <a:t>The </a:t>
+            </a:r>
+            <a:r>
+              <a:rPr sz="2000" b="1">
+                <a:latin typeface="Courier"/>
+              </a:rPr>
+              <a:t>NA</a:t>
+            </a:r>
+            <a:r>
+              <a:rPr sz="2000" b="1"/>
+              <a:t>s are honest.</a:t>
+            </a:r>
+            <a:r>
+              <a:rPr sz="2000"/>
+              <a:t> One team never weighed their tracings, so those leaves have no area. R keeps the gap instead of inventing a number.</a:t>
             </a:r>
           </a:p>
         </p:txBody>
@@ -10642,7 +10871,7 @@
             </a:pPr>
             <a:r>
               <a:rPr/>
-              <a:t>Convert a Whole Column of Tracings</a:t>
+              <a:t>One Value per Team per Side</a:t>
             </a:r>
           </a:p>
         </p:txBody>
@@ -10672,7 +10901,7 @@
                 </a:solidFill>
                 <a:latin typeface="Courier"/>
               </a:rPr>
-              <a:t># Load our leaf data ----------------------------------</a:t>
+              <a:t># Average away the pseudoreplication ------------------</a:t>
             </a:r>
             <a:br/>
             <a:r>
@@ -10682,7 +10911,16 @@
                 </a:solidFill>
                 <a:latin typeface="Courier"/>
               </a:rPr>
-              <a:t>leaf_df &lt;-</a:t>
+              <a:t>team_df &lt;- leaf_df </a:t>
+            </a:r>
+            <a:r>
+              <a:rPr>
+                <a:solidFill>
+                  <a:srgbClr val="5E5E5E"/>
+                </a:solidFill>
+                <a:latin typeface="Courier"/>
+              </a:rPr>
+              <a:t>%&gt;%</a:t>
             </a:r>
             <a:br/>
             <a:r>
@@ -10701,7 +10939,7 @@
                 </a:solidFill>
                 <a:latin typeface="Courier"/>
               </a:rPr>
-              <a:t>read_excel</a:t>
+              <a:t>group_by</a:t>
             </a:r>
             <a:r>
               <a:rPr>
@@ -10710,16 +10948,235 @@
                 </a:solidFill>
                 <a:latin typeface="Courier"/>
               </a:rPr>
+              <a:t>(teams, shade) </a:t>
+            </a:r>
+            <a:r>
+              <a:rPr>
+                <a:solidFill>
+                  <a:srgbClr val="5E5E5E"/>
+                </a:solidFill>
+                <a:latin typeface="Courier"/>
+              </a:rPr>
+              <a:t>%&gt;%</a:t>
+            </a:r>
+            <a:br/>
+            <a:r>
+              <a:rPr>
+                <a:solidFill>
+                  <a:srgbClr val="003B4F"/>
+                </a:solidFill>
+                <a:latin typeface="Courier"/>
+              </a:rPr>
+              <a:t>  </a:t>
+            </a:r>
+            <a:r>
+              <a:rPr>
+                <a:solidFill>
+                  <a:srgbClr val="4758AB"/>
+                </a:solidFill>
+                <a:latin typeface="Courier"/>
+              </a:rPr>
+              <a:t>summarize</a:t>
+            </a:r>
+            <a:r>
+              <a:rPr>
+                <a:solidFill>
+                  <a:srgbClr val="003B4F"/>
+                </a:solidFill>
+                <a:latin typeface="Courier"/>
+              </a:rPr>
               <a:t>(</a:t>
             </a:r>
             <a:r>
               <a:rPr>
                 <a:solidFill>
+                  <a:srgbClr val="657422"/>
+                </a:solidFill>
+                <a:latin typeface="Courier"/>
+              </a:rPr>
+              <a:t>area_cm2 =</a:t>
+            </a:r>
+            <a:r>
+              <a:rPr>
+                <a:solidFill>
+                  <a:srgbClr val="003B4F"/>
+                </a:solidFill>
+                <a:latin typeface="Courier"/>
+              </a:rPr>
+              <a:t> </a:t>
+            </a:r>
+            <a:r>
+              <a:rPr>
+                <a:solidFill>
+                  <a:srgbClr val="4758AB"/>
+                </a:solidFill>
+                <a:latin typeface="Courier"/>
+              </a:rPr>
+              <a:t>mean</a:t>
+            </a:r>
+            <a:r>
+              <a:rPr>
+                <a:solidFill>
+                  <a:srgbClr val="003B4F"/>
+                </a:solidFill>
+                <a:latin typeface="Courier"/>
+              </a:rPr>
+              <a:t>(area_cm2, </a:t>
+            </a:r>
+            <a:r>
+              <a:rPr>
+                <a:solidFill>
+                  <a:srgbClr val="657422"/>
+                </a:solidFill>
+                <a:latin typeface="Courier"/>
+              </a:rPr>
+              <a:t>na.rm =</a:t>
+            </a:r>
+            <a:r>
+              <a:rPr>
+                <a:solidFill>
+                  <a:srgbClr val="003B4F"/>
+                </a:solidFill>
+                <a:latin typeface="Courier"/>
+              </a:rPr>
+              <a:t> </a:t>
+            </a:r>
+            <a:r>
+              <a:rPr>
+                <a:solidFill>
+                  <a:srgbClr val="8F5902"/>
+                </a:solidFill>
+                <a:latin typeface="Courier"/>
+              </a:rPr>
+              <a:t>TRUE</a:t>
+            </a:r>
+            <a:r>
+              <a:rPr>
+                <a:solidFill>
+                  <a:srgbClr val="003B4F"/>
+                </a:solidFill>
+                <a:latin typeface="Courier"/>
+              </a:rPr>
+              <a:t>),</a:t>
+            </a:r>
+            <a:br/>
+            <a:r>
+              <a:rPr>
+                <a:solidFill>
+                  <a:srgbClr val="003B4F"/>
+                </a:solidFill>
+                <a:latin typeface="Courier"/>
+              </a:rPr>
+              <a:t>            </a:t>
+            </a:r>
+            <a:r>
+              <a:rPr>
+                <a:solidFill>
+                  <a:srgbClr val="657422"/>
+                </a:solidFill>
+                <a:latin typeface="Courier"/>
+              </a:rPr>
+              <a:t>mass_g   =</a:t>
+            </a:r>
+            <a:r>
+              <a:rPr>
+                <a:solidFill>
+                  <a:srgbClr val="003B4F"/>
+                </a:solidFill>
+                <a:latin typeface="Courier"/>
+              </a:rPr>
+              <a:t> </a:t>
+            </a:r>
+            <a:r>
+              <a:rPr>
+                <a:solidFill>
+                  <a:srgbClr val="4758AB"/>
+                </a:solidFill>
+                <a:latin typeface="Courier"/>
+              </a:rPr>
+              <a:t>mean</a:t>
+            </a:r>
+            <a:r>
+              <a:rPr>
+                <a:solidFill>
+                  <a:srgbClr val="003B4F"/>
+                </a:solidFill>
+                <a:latin typeface="Courier"/>
+              </a:rPr>
+              <a:t>(mass_g,   </a:t>
+            </a:r>
+            <a:r>
+              <a:rPr>
+                <a:solidFill>
+                  <a:srgbClr val="657422"/>
+                </a:solidFill>
+                <a:latin typeface="Courier"/>
+              </a:rPr>
+              <a:t>na.rm =</a:t>
+            </a:r>
+            <a:r>
+              <a:rPr>
+                <a:solidFill>
+                  <a:srgbClr val="003B4F"/>
+                </a:solidFill>
+                <a:latin typeface="Courier"/>
+              </a:rPr>
+              <a:t> </a:t>
+            </a:r>
+            <a:r>
+              <a:rPr>
+                <a:solidFill>
+                  <a:srgbClr val="8F5902"/>
+                </a:solidFill>
+                <a:latin typeface="Courier"/>
+              </a:rPr>
+              <a:t>TRUE</a:t>
+            </a:r>
+            <a:r>
+              <a:rPr>
+                <a:solidFill>
+                  <a:srgbClr val="003B4F"/>
+                </a:solidFill>
+                <a:latin typeface="Courier"/>
+              </a:rPr>
+              <a:t>),</a:t>
+            </a:r>
+            <a:br/>
+            <a:r>
+              <a:rPr>
+                <a:solidFill>
+                  <a:srgbClr val="003B4F"/>
+                </a:solidFill>
+                <a:latin typeface="Courier"/>
+              </a:rPr>
+              <a:t>            </a:t>
+            </a:r>
+            <a:r>
+              <a:rPr>
+                <a:solidFill>
+                  <a:srgbClr val="657422"/>
+                </a:solidFill>
+                <a:latin typeface="Courier"/>
+              </a:rPr>
+              <a:t>.groups  =</a:t>
+            </a:r>
+            <a:r>
+              <a:rPr>
+                <a:solidFill>
+                  <a:srgbClr val="003B4F"/>
+                </a:solidFill>
+                <a:latin typeface="Courier"/>
+              </a:rPr>
+              <a:t> </a:t>
+            </a:r>
+            <a:r>
+              <a:rPr>
+                <a:solidFill>
                   <a:srgbClr val="20794D"/>
                 </a:solidFill>
                 <a:latin typeface="Courier"/>
               </a:rPr>
-              <a:t>"data/2026_09_03_data_sci_leaf_area.xlsx"</a:t>
+              <a:t>"drop"</a:t>
             </a:r>
             <a:r>
               <a:rPr>
@@ -10728,290 +11185,18 @@
                 </a:solidFill>
                 <a:latin typeface="Courier"/>
               </a:rPr>
-              <a:t>) </a:t>
-            </a:r>
-            <a:r>
-              <a:rPr>
-                <a:solidFill>
-                  <a:srgbClr val="5E5E5E"/>
-                </a:solidFill>
-                <a:latin typeface="Courier"/>
-              </a:rPr>
-              <a:t>%&gt;%</a:t>
-            </a:r>
-            <a:br/>
-            <a:r>
-              <a:rPr>
-                <a:solidFill>
-                  <a:srgbClr val="003B4F"/>
-                </a:solidFill>
-                <a:latin typeface="Courier"/>
-              </a:rPr>
-              <a:t>  </a:t>
-            </a:r>
-            <a:r>
-              <a:rPr>
-                <a:solidFill>
-                  <a:srgbClr val="4758AB"/>
-                </a:solidFill>
-                <a:latin typeface="Courier"/>
-              </a:rPr>
-              <a:t>clean_names</a:t>
-            </a:r>
-            <a:r>
-              <a:rPr>
-                <a:solidFill>
-                  <a:srgbClr val="003B4F"/>
-                </a:solidFill>
-                <a:latin typeface="Courier"/>
-              </a:rPr>
-              <a:t>()</a:t>
+              <a:t>)</a:t>
             </a:r>
             <a:br/>
             <a:br/>
             <a:r>
               <a:rPr>
                 <a:solidFill>
-                  <a:srgbClr val="5E5E5E"/>
-                </a:solidFill>
-                <a:latin typeface="Courier"/>
-              </a:rPr>
-              <a:t># Turn every tracing mass into an area ----------------</a:t>
-            </a:r>
-            <a:br/>
-            <a:r>
-              <a:rPr>
-                <a:solidFill>
                   <a:srgbClr val="003B4F"/>
                 </a:solidFill>
                 <a:latin typeface="Courier"/>
               </a:rPr>
-              <a:t>leaf_df &lt;- leaf_df </a:t>
-            </a:r>
-            <a:r>
-              <a:rPr>
-                <a:solidFill>
-                  <a:srgbClr val="5E5E5E"/>
-                </a:solidFill>
-                <a:latin typeface="Courier"/>
-              </a:rPr>
-              <a:t>%&gt;%</a:t>
-            </a:r>
-            <a:br/>
-            <a:r>
-              <a:rPr>
-                <a:solidFill>
-                  <a:srgbClr val="003B4F"/>
-                </a:solidFill>
-                <a:latin typeface="Courier"/>
-              </a:rPr>
-              <a:t>  </a:t>
-            </a:r>
-            <a:r>
-              <a:rPr>
-                <a:solidFill>
-                  <a:srgbClr val="4758AB"/>
-                </a:solidFill>
-                <a:latin typeface="Courier"/>
-              </a:rPr>
-              <a:t>mutate</a:t>
-            </a:r>
-            <a:r>
-              <a:rPr>
-                <a:solidFill>
-                  <a:srgbClr val="003B4F"/>
-                </a:solidFill>
-                <a:latin typeface="Courier"/>
-              </a:rPr>
-              <a:t>(</a:t>
-            </a:r>
-            <a:br/>
-            <a:r>
-              <a:rPr>
-                <a:solidFill>
-                  <a:srgbClr val="003B4F"/>
-                </a:solidFill>
-                <a:latin typeface="Courier"/>
-              </a:rPr>
-              <a:t>    </a:t>
-            </a:r>
-            <a:r>
-              <a:rPr>
-                <a:solidFill>
-                  <a:srgbClr val="657422"/>
-                </a:solidFill>
-                <a:latin typeface="Courier"/>
-              </a:rPr>
-              <a:t>leaf_area_cm2 =</a:t>
-            </a:r>
-            <a:r>
-              <a:rPr>
-                <a:solidFill>
-                  <a:srgbClr val="003B4F"/>
-                </a:solidFill>
-                <a:latin typeface="Courier"/>
-              </a:rPr>
-              <a:t> </a:t>
-            </a:r>
-            <a:r>
-              <a:rPr>
-                <a:solidFill>
-                  <a:srgbClr val="4758AB"/>
-                </a:solidFill>
-                <a:latin typeface="Courier"/>
-              </a:rPr>
-              <a:t>predict</a:t>
-            </a:r>
-            <a:r>
-              <a:rPr>
-                <a:solidFill>
-                  <a:srgbClr val="003B4F"/>
-                </a:solidFill>
-                <a:latin typeface="Courier"/>
-              </a:rPr>
-              <a:t>(</a:t>
-            </a:r>
-            <a:br/>
-            <a:r>
-              <a:rPr>
-                <a:solidFill>
-                  <a:srgbClr val="003B4F"/>
-                </a:solidFill>
-                <a:latin typeface="Courier"/>
-              </a:rPr>
-              <a:t>      paper_lm_model,</a:t>
-            </a:r>
-            <a:br/>
-            <a:r>
-              <a:rPr>
-                <a:solidFill>
-                  <a:srgbClr val="003B4F"/>
-                </a:solidFill>
-                <a:latin typeface="Courier"/>
-              </a:rPr>
-              <a:t>      </a:t>
-            </a:r>
-            <a:r>
-              <a:rPr>
-                <a:solidFill>
-                  <a:srgbClr val="657422"/>
-                </a:solidFill>
-                <a:latin typeface="Courier"/>
-              </a:rPr>
-              <a:t>newdata =</a:t>
-            </a:r>
-            <a:r>
-              <a:rPr>
-                <a:solidFill>
-                  <a:srgbClr val="003B4F"/>
-                </a:solidFill>
-                <a:latin typeface="Courier"/>
-              </a:rPr>
-              <a:t> </a:t>
-            </a:r>
-            <a:r>
-              <a:rPr>
-                <a:solidFill>
-                  <a:srgbClr val="4758AB"/>
-                </a:solidFill>
-                <a:latin typeface="Courier"/>
-              </a:rPr>
-              <a:t>tibble</a:t>
-            </a:r>
-            <a:r>
-              <a:rPr>
-                <a:solidFill>
-                  <a:srgbClr val="003B4F"/>
-                </a:solidFill>
-                <a:latin typeface="Courier"/>
-              </a:rPr>
-              <a:t>(</a:t>
-            </a:r>
-            <a:r>
-              <a:rPr>
-                <a:solidFill>
-                  <a:srgbClr val="657422"/>
-                </a:solidFill>
-                <a:latin typeface="Courier"/>
-              </a:rPr>
-              <a:t>mass_g =</a:t>
-            </a:r>
-            <a:r>
-              <a:rPr>
-                <a:solidFill>
-                  <a:srgbClr val="003B4F"/>
-                </a:solidFill>
-                <a:latin typeface="Courier"/>
-              </a:rPr>
-              <a:t> paper_mass_g)</a:t>
-            </a:r>
-            <a:br/>
-            <a:r>
-              <a:rPr>
-                <a:solidFill>
-                  <a:srgbClr val="003B4F"/>
-                </a:solidFill>
-                <a:latin typeface="Courier"/>
-              </a:rPr>
-              <a:t>    )</a:t>
-            </a:r>
-            <a:br/>
-            <a:r>
-              <a:rPr>
-                <a:solidFill>
-                  <a:srgbClr val="003B4F"/>
-                </a:solidFill>
-                <a:latin typeface="Courier"/>
-              </a:rPr>
-              <a:t>  )</a:t>
-            </a:r>
-            <a:br/>
-            <a:br/>
-            <a:r>
-              <a:rPr>
-                <a:solidFill>
-                  <a:srgbClr val="003B4F"/>
-                </a:solidFill>
-                <a:latin typeface="Courier"/>
-              </a:rPr>
-              <a:t>leaf_df </a:t>
-            </a:r>
-            <a:r>
-              <a:rPr>
-                <a:solidFill>
-                  <a:srgbClr val="5E5E5E"/>
-                </a:solidFill>
-                <a:latin typeface="Courier"/>
-              </a:rPr>
-              <a:t>%&gt;%</a:t>
-            </a:r>
-            <a:br/>
-            <a:r>
-              <a:rPr>
-                <a:solidFill>
-                  <a:srgbClr val="003B4F"/>
-                </a:solidFill>
-                <a:latin typeface="Courier"/>
-              </a:rPr>
-              <a:t>  </a:t>
-            </a:r>
-            <a:r>
-              <a:rPr>
-                <a:solidFill>
-                  <a:srgbClr val="4758AB"/>
-                </a:solidFill>
-                <a:latin typeface="Courier"/>
-              </a:rPr>
-              <a:t>select</a:t>
-            </a:r>
-            <a:r>
-              <a:rPr>
-                <a:solidFill>
-                  <a:srgbClr val="003B4F"/>
-                </a:solidFill>
-                <a:latin typeface="Courier"/>
-              </a:rPr>
-              <a:t>(teams, shade, mass_g, paper_mass_g, leaf_area_cm2)</a:t>
+              <a:t>team_df</a:t>
             </a:r>
           </a:p>
           <a:p>
@@ -11022,20 +11207,19 @@
               <a:rPr>
                 <a:latin typeface="Courier"/>
               </a:rPr>
-              <a:t># A tibble: 53 × 5
-   teams shade mass_g paper_mass_g leaf_area_cm2
-   &lt;chr&gt; &lt;chr&gt;  &lt;dbl&gt;        &lt;dbl&gt;         &lt;dbl&gt;
- 1 12345 sunny   0.4          0.21          27.7
- 2 12345 sunny   0.48         0.21          27.7
- 3 12345 sunny   0.34         0.21          27.7
- 4 12345 sunny   0.65         0.24          31.6
- 5 12345 sunny   0.27         0.15          19.9
- 6 12345 sunny   0.43         0.34          44.7
- 7 12345 shady   0.39         0.29          38.1
- 8 12345 shady   0.45         0.25          32.9
- 9 12345 shady   0.6          0.23          30.3
-10 12345 shady   0.57         0.28          36.8
-# ℹ 43 more rows</a:t>
+              <a:t># A tibble: 10 × 4
+   teams              shade area_cm2 mass_g
+   &lt;chr&gt;              &lt;chr&gt;    &lt;dbl&gt;  &lt;dbl&gt;
+ 1 12345              shady     34.0  0.448
+ 2 12345              sunny     29.9  0.428
+ 3 Oscar_Karl         shady    NaN    0.400
+ 4 Oscar_Karl         sunny    NaN    0.339
+ 5 fighting_mongooses shady     35.7  0.653
+ 6 fighting_mongooses sunny     32.2  0.544
+ 7 leaf_oglers        shady     36.3  0.588
+ 8 leaf_oglers        sunny     37.4  0.599
+ 9 still_loading      shady     42.5  0.526
+10 still_loading      sunny     53.7  0.789</a:t>
             </a:r>
           </a:p>
         </p:txBody>
@@ -11055,79 +11239,60 @@
           <a:bodyPr/>
           <a:lstStyle/>
           <a:p>
-            <a:pPr lvl="0" indent="0" marL="0">
-              <a:buNone/>
-            </a:pPr>
+            <a:pPr lvl="0"/>
+            <a:r>
+              <a:rPr/>
+              <a:t>Six leaves off one branch are </a:t>
+            </a:r>
             <a:r>
               <a:rPr b="1"/>
-              <a:t>This is the payoff.</a:t>
-            </a:r>
-            <a:r>
-              <a:rPr/>
-              <a:t> </a:t>
-            </a:r>
-            <a:r>
-              <a:rPr>
-                <a:latin typeface="Courier"/>
-              </a:rPr>
-              <a:t>paper_mass_g</a:t>
-            </a:r>
-            <a:r>
-              <a:rPr/>
-              <a:t> was the mass of each leaf’s tracing. Now every leaf has a </a:t>
-            </a:r>
-            <a:r>
-              <a:rPr b="1">
-                <a:latin typeface="Courier"/>
-              </a:rPr>
-              <a:t>leaf_area_cm2</a:t>
-            </a:r>
-            <a:r>
-              <a:rPr/>
-              <a:t>.</a:t>
-            </a:r>
-          </a:p>
-          <a:p>
-            <a:pPr lvl="0" indent="0" marL="0">
-              <a:buNone/>
-            </a:pPr>
+              <a:t>not six independent measurements</a:t>
+            </a:r>
+          </a:p>
+          <a:p>
+            <a:pPr lvl="0"/>
+            <a:r>
+              <a:rPr/>
+              <a:t>Using all 53 is </a:t>
+            </a:r>
             <a:r>
               <a:rPr b="1"/>
-              <a:t>The one fiddly bit</a:t>
-            </a:r>
-            <a:r>
-              <a:rPr/>
-              <a:t> is the same rule as before: </a:t>
-            </a:r>
-            <a:r>
-              <a:rPr>
-                <a:latin typeface="Courier"/>
-              </a:rPr>
-              <a:t>predict()</a:t>
-            </a:r>
-            <a:r>
-              <a:rPr/>
-              <a:t> wants a column called </a:t>
-            </a:r>
-            <a:r>
-              <a:rPr>
-                <a:latin typeface="Courier"/>
-              </a:rPr>
-              <a:t>mass_g</a:t>
-            </a:r>
-            <a:r>
-              <a:rPr/>
-              <a:t>, so we hand it </a:t>
-            </a:r>
-            <a:r>
-              <a:rPr>
-                <a:latin typeface="Courier"/>
-              </a:rPr>
-              <a:t>tibble(mass_g = paper_mass_g)</a:t>
-            </a:r>
-            <a:r>
-              <a:rPr/>
-              <a:t> — our tracing masses, under the name the model knows.</a:t>
+              <a:t>pseudoreplication</a:t>
+            </a:r>
+            <a:r>
+              <a:rPr/>
+              <a:t> — it makes </a:t>
+            </a:r>
+            <a:r>
+              <a:rPr i="1"/>
+              <a:t>p</a:t>
+            </a:r>
+            <a:r>
+              <a:rPr/>
+              <a:t> look better than the study earned</a:t>
+            </a:r>
+          </a:p>
+          <a:p>
+            <a:pPr lvl="0"/>
+            <a:r>
+              <a:rPr/>
+              <a:t>Averaging gives each team </a:t>
+            </a:r>
+            <a:r>
+              <a:rPr b="1"/>
+              <a:t>one</a:t>
+            </a:r>
+            <a:r>
+              <a:rPr/>
+              <a:t> sunny and </a:t>
+            </a:r>
+            <a:r>
+              <a:rPr b="1"/>
+              <a:t>one</a:t>
+            </a:r>
+            <a:r>
+              <a:rPr/>
+              <a:t> shady value</a:t>
             </a:r>
           </a:p>
           <a:p>
@@ -11144,32 +11309,16 @@
               <a:buNone/>
             </a:pPr>
             <a:r>
+              <a:rPr sz="2000"/>
+              <a:t>You met this in T-Tests II. Same tree, same pairing — now in </a:t>
+            </a:r>
+            <a:r>
               <a:rPr sz="2000" b="1"/>
-              <a:t>The </a:t>
-            </a:r>
-            <a:r>
-              <a:rPr sz="2000" b="1">
-                <a:latin typeface="Courier"/>
-              </a:rPr>
-              <a:t>NA</a:t>
-            </a:r>
-            <a:r>
-              <a:rPr sz="2000" b="1"/>
-              <a:t>s are honest.</a:t>
+              <a:t>cm²</a:t>
             </a:r>
             <a:r>
               <a:rPr sz="2000"/>
-              <a:t> One team never weighed their tracings, so those leaves have no area. </a:t>
-            </a:r>
-            <a:r>
-              <a:rPr sz="2000">
-                <a:latin typeface="Courier"/>
-              </a:rPr>
-              <a:t>predict()</a:t>
-            </a:r>
-            <a:r>
-              <a:rPr sz="2000"/>
-              <a:t> passes the missing value straight through instead of inventing a number.</a:t>
+              <a:t> instead of grams.</a:t>
             </a:r>
           </a:p>
         </p:txBody>
@@ -11375,17 +11524,7 @@
                 </a:r>
                 <a:r>
                   <a:rPr/>
-                  <a:t> </a:t>
-                </a:r>
-                <a:r>
-                  <a:rPr>
-                    <a:latin typeface="Courier"/>
-                  </a:rPr>
-                  <a:t>predict()</a:t>
-                </a:r>
-                <a:r>
-                  <a:rPr/>
-                  <a:t> to turn a tracing mass into a leaf area</a:t>
+                  <a:t> the slope to turn a tracing mass into a leaf area</a:t>
                 </a:r>
               </a:p>
               <a:p>
@@ -11466,14 +11605,18 @@
           <a:p>
             <a:pPr lvl="1"/>
             <a:r>
-              <a:rPr>
-                <a:latin typeface="Courier"/>
-              </a:rPr>
-              <a:t>predict()</a:t>
-            </a:r>
-            <a:r>
-              <a:rPr/>
-              <a:t> — make predictions</a:t>
+              <a:rPr/>
+              <a:t>reading </a:t>
+            </a:r>
+            <a:r>
+              <a:rPr>
+                <a:latin typeface="Courier"/>
+              </a:rPr>
+              <a:t>7.660e-03</a:t>
+            </a:r>
+            <a:r>
+              <a:rPr/>
+              <a:t> as 0.007660</a:t>
             </a:r>
           </a:p>
           <a:p>
@@ -11617,7 +11760,15 @@
             </a:pPr>
             <a:r>
               <a:rPr/>
-              <a:t>Was the Area Different Between Sides?</a:t>
+              <a:t>Paired </a:t>
+            </a:r>
+            <a:r>
+              <a:rPr i="1"/>
+              <a:t>t</a:t>
+            </a:r>
+            <a:r>
+              <a:rPr/>
+              <a:t>-Tests on Area and Mass</a:t>
             </a:r>
           </a:p>
         </p:txBody>
@@ -11647,7 +11798,7 @@
                 </a:solidFill>
                 <a:latin typeface="Courier"/>
               </a:rPr>
-              <a:t># Predicted leaf area by side -------------------------</a:t>
+              <a:t># One row per team ------------------------------------</a:t>
             </a:r>
             <a:br/>
             <a:r>
@@ -11657,7 +11808,7 @@
                 </a:solidFill>
                 <a:latin typeface="Courier"/>
               </a:rPr>
-              <a:t>leaf_area_plot &lt;- leaf_df </a:t>
+              <a:t>wide_df &lt;- team_df </a:t>
             </a:r>
             <a:r>
               <a:rPr>
@@ -11685,7 +11836,7 @@
                 </a:solidFill>
                 <a:latin typeface="Courier"/>
               </a:rPr>
-              <a:t>ggplot</a:t>
+              <a:t>pivot_wider</a:t>
             </a:r>
             <a:r>
               <a:rPr>
@@ -11699,11 +11850,57 @@
             <a:r>
               <a:rPr>
                 <a:solidFill>
+                  <a:srgbClr val="657422"/>
+                </a:solidFill>
+                <a:latin typeface="Courier"/>
+              </a:rPr>
+              <a:t>names_from =</a:t>
+            </a:r>
+            <a:r>
+              <a:rPr>
+                <a:solidFill>
+                  <a:srgbClr val="003B4F"/>
+                </a:solidFill>
+                <a:latin typeface="Courier"/>
+              </a:rPr>
+              <a:t> shade,</a:t>
+            </a:r>
+            <a:br/>
+            <a:r>
+              <a:rPr>
+                <a:solidFill>
+                  <a:srgbClr val="003B4F"/>
+                </a:solidFill>
+                <a:latin typeface="Courier"/>
+              </a:rPr>
+              <a:t>              </a:t>
+            </a:r>
+            <a:r>
+              <a:rPr>
+                <a:solidFill>
+                  <a:srgbClr val="657422"/>
+                </a:solidFill>
+                <a:latin typeface="Courier"/>
+              </a:rPr>
+              <a:t>values_from =</a:t>
+            </a:r>
+            <a:r>
+              <a:rPr>
+                <a:solidFill>
+                  <a:srgbClr val="003B4F"/>
+                </a:solidFill>
+                <a:latin typeface="Courier"/>
+              </a:rPr>
+              <a:t> </a:t>
+            </a:r>
+            <a:r>
+              <a:rPr>
+                <a:solidFill>
                   <a:srgbClr val="4758AB"/>
                 </a:solidFill>
                 <a:latin typeface="Courier"/>
               </a:rPr>
-              <a:t>aes</a:t>
+              <a:t>c</a:t>
             </a:r>
             <a:r>
               <a:rPr>
@@ -11712,7 +11909,73 @@
                 </a:solidFill>
                 <a:latin typeface="Courier"/>
               </a:rPr>
-              <a:t>(</a:t>
+              <a:t>(area_cm2, mass_g))</a:t>
+            </a:r>
+            <a:br/>
+            <a:br/>
+            <a:r>
+              <a:rPr>
+                <a:solidFill>
+                  <a:srgbClr val="4758AB"/>
+                </a:solidFill>
+                <a:latin typeface="Courier"/>
+              </a:rPr>
+              <a:t>t.test</a:t>
+            </a:r>
+            <a:r>
+              <a:rPr>
+                <a:solidFill>
+                  <a:srgbClr val="003B4F"/>
+                </a:solidFill>
+                <a:latin typeface="Courier"/>
+              </a:rPr>
+              <a:t>(wide_df</a:t>
+            </a:r>
+            <a:r>
+              <a:rPr>
+                <a:solidFill>
+                  <a:srgbClr val="5E5E5E"/>
+                </a:solidFill>
+                <a:latin typeface="Courier"/>
+              </a:rPr>
+              <a:t>$</a:t>
+            </a:r>
+            <a:r>
+              <a:rPr>
+                <a:solidFill>
+                  <a:srgbClr val="003B4F"/>
+                </a:solidFill>
+                <a:latin typeface="Courier"/>
+              </a:rPr>
+              <a:t>area_cm2_shady,</a:t>
+            </a:r>
+            <a:br/>
+            <a:r>
+              <a:rPr>
+                <a:solidFill>
+                  <a:srgbClr val="003B4F"/>
+                </a:solidFill>
+                <a:latin typeface="Courier"/>
+              </a:rPr>
+              <a:t>       wide_df</a:t>
+            </a:r>
+            <a:r>
+              <a:rPr>
+                <a:solidFill>
+                  <a:srgbClr val="5E5E5E"/>
+                </a:solidFill>
+                <a:latin typeface="Courier"/>
+              </a:rPr>
+              <a:t>$</a:t>
+            </a:r>
+            <a:r>
+              <a:rPr>
+                <a:solidFill>
+                  <a:srgbClr val="003B4F"/>
+                </a:solidFill>
+                <a:latin typeface="Courier"/>
+              </a:rPr>
+              <a:t>area_cm2_sunny, </a:t>
             </a:r>
             <a:r>
               <a:rPr>
@@ -11721,7 +11984,7 @@
                 </a:solidFill>
                 <a:latin typeface="Courier"/>
               </a:rPr>
-              <a:t>x =</a:t>
+              <a:t>paired =</a:t>
             </a:r>
             <a:r>
               <a:rPr>
@@ -11730,7 +11993,91 @@
                 </a:solidFill>
                 <a:latin typeface="Courier"/>
               </a:rPr>
-              <a:t> shade, </a:t>
+              <a:t> </a:t>
+            </a:r>
+            <a:r>
+              <a:rPr>
+                <a:solidFill>
+                  <a:srgbClr val="8F5902"/>
+                </a:solidFill>
+                <a:latin typeface="Courier"/>
+              </a:rPr>
+              <a:t>TRUE</a:t>
+            </a:r>
+            <a:r>
+              <a:rPr>
+                <a:solidFill>
+                  <a:srgbClr val="003B4F"/>
+                </a:solidFill>
+                <a:latin typeface="Courier"/>
+              </a:rPr>
+              <a:t>)</a:t>
+            </a:r>
+            <a:br/>
+            <a:br/>
+            <a:r>
+              <a:rPr>
+                <a:solidFill>
+                  <a:srgbClr val="4758AB"/>
+                </a:solidFill>
+                <a:latin typeface="Courier"/>
+              </a:rPr>
+              <a:t>t.test</a:t>
+            </a:r>
+            <a:r>
+              <a:rPr>
+                <a:solidFill>
+                  <a:srgbClr val="003B4F"/>
+                </a:solidFill>
+                <a:latin typeface="Courier"/>
+              </a:rPr>
+              <a:t>(wide_df</a:t>
+            </a:r>
+            <a:r>
+              <a:rPr>
+                <a:solidFill>
+                  <a:srgbClr val="5E5E5E"/>
+                </a:solidFill>
+                <a:latin typeface="Courier"/>
+              </a:rPr>
+              <a:t>$</a:t>
+            </a:r>
+            <a:r>
+              <a:rPr>
+                <a:solidFill>
+                  <a:srgbClr val="003B4F"/>
+                </a:solidFill>
+                <a:latin typeface="Courier"/>
+              </a:rPr>
+              <a:t>mass_g_shady,</a:t>
+            </a:r>
+            <a:br/>
+            <a:r>
+              <a:rPr>
+                <a:solidFill>
+                  <a:srgbClr val="003B4F"/>
+                </a:solidFill>
+                <a:latin typeface="Courier"/>
+              </a:rPr>
+              <a:t>       wide_df</a:t>
+            </a:r>
+            <a:r>
+              <a:rPr>
+                <a:solidFill>
+                  <a:srgbClr val="5E5E5E"/>
+                </a:solidFill>
+                <a:latin typeface="Courier"/>
+              </a:rPr>
+              <a:t>$</a:t>
+            </a:r>
+            <a:r>
+              <a:rPr>
+                <a:solidFill>
+                  <a:srgbClr val="003B4F"/>
+                </a:solidFill>
+                <a:latin typeface="Courier"/>
+              </a:rPr>
+              <a:t>mass_g_sunny, </a:t>
             </a:r>
             <a:r>
               <a:rPr>
@@ -11739,7 +12086,7 @@
                 </a:solidFill>
                 <a:latin typeface="Courier"/>
               </a:rPr>
-              <a:t>y =</a:t>
+              <a:t>paired =</a:t>
             </a:r>
             <a:r>
               <a:rPr>
@@ -11748,18 +12095,17 @@
                 </a:solidFill>
                 <a:latin typeface="Courier"/>
               </a:rPr>
-              <a:t> leaf_area_cm2)) </a:t>
-            </a:r>
-            <a:r>
-              <a:rPr>
-                <a:solidFill>
-                  <a:srgbClr val="5E5E5E"/>
-                </a:solidFill>
-                <a:latin typeface="Courier"/>
-              </a:rPr>
-              <a:t>+</a:t>
-            </a:r>
-            <a:br/>
+              <a:t> </a:t>
+            </a:r>
+            <a:r>
+              <a:rPr>
+                <a:solidFill>
+                  <a:srgbClr val="8F5902"/>
+                </a:solidFill>
+                <a:latin typeface="Courier"/>
+              </a:rPr>
+              <a:t>TRUE</a:t>
+            </a:r>
             <a:r>
               <a:rPr>
                 <a:solidFill>
@@ -11767,142 +12113,11 @@
                 </a:solidFill>
                 <a:latin typeface="Courier"/>
               </a:rPr>
-              <a:t>  </a:t>
-            </a:r>
-            <a:r>
-              <a:rPr>
-                <a:solidFill>
-                  <a:srgbClr val="4758AB"/>
-                </a:solidFill>
-                <a:latin typeface="Courier"/>
-              </a:rPr>
-              <a:t>geom_boxplot</a:t>
-            </a:r>
-            <a:r>
-              <a:rPr>
-                <a:solidFill>
-                  <a:srgbClr val="003B4F"/>
-                </a:solidFill>
-                <a:latin typeface="Courier"/>
-              </a:rPr>
-              <a:t>() </a:t>
-            </a:r>
-            <a:r>
-              <a:rPr>
-                <a:solidFill>
-                  <a:srgbClr val="5E5E5E"/>
-                </a:solidFill>
-                <a:latin typeface="Courier"/>
-              </a:rPr>
-              <a:t>+</a:t>
-            </a:r>
-            <a:br/>
-            <a:r>
-              <a:rPr>
-                <a:solidFill>
-                  <a:srgbClr val="003B4F"/>
-                </a:solidFill>
-                <a:latin typeface="Courier"/>
-              </a:rPr>
-              <a:t>  </a:t>
-            </a:r>
-            <a:r>
-              <a:rPr>
-                <a:solidFill>
-                  <a:srgbClr val="4758AB"/>
-                </a:solidFill>
-                <a:latin typeface="Courier"/>
-              </a:rPr>
-              <a:t>geom_jitter</a:t>
-            </a:r>
-            <a:r>
-              <a:rPr>
-                <a:solidFill>
-                  <a:srgbClr val="003B4F"/>
-                </a:solidFill>
-                <a:latin typeface="Courier"/>
-              </a:rPr>
-              <a:t>(</a:t>
-            </a:r>
-            <a:r>
-              <a:rPr>
-                <a:solidFill>
-                  <a:srgbClr val="657422"/>
-                </a:solidFill>
-                <a:latin typeface="Courier"/>
-              </a:rPr>
-              <a:t>width =</a:t>
-            </a:r>
-            <a:r>
-              <a:rPr>
-                <a:solidFill>
-                  <a:srgbClr val="003B4F"/>
-                </a:solidFill>
-                <a:latin typeface="Courier"/>
-              </a:rPr>
-              <a:t> </a:t>
-            </a:r>
-            <a:r>
-              <a:rPr>
-                <a:solidFill>
-                  <a:srgbClr val="AD0000"/>
-                </a:solidFill>
-                <a:latin typeface="Courier"/>
-              </a:rPr>
-              <a:t>0.15</a:t>
-            </a:r>
-            <a:r>
-              <a:rPr>
-                <a:solidFill>
-                  <a:srgbClr val="003B4F"/>
-                </a:solidFill>
-                <a:latin typeface="Courier"/>
-              </a:rPr>
               <a:t>)</a:t>
-            </a:r>
-            <a:br/>
-            <a:r>
-              <a:rPr>
-                <a:solidFill>
-                  <a:srgbClr val="003B4F"/>
-                </a:solidFill>
-                <a:latin typeface="Courier"/>
-              </a:rPr>
-              <a:t>leaf_area_plot</a:t>
             </a:r>
           </a:p>
         </p:txBody>
       </p:sp>
-      <p:pic>
-        <p:nvPicPr>
-          <p:cNvPr descr="regression_lecture_files/figure-pptx/leaf-area-plot-11-1.png" id="0" name="Picture 1"/>
-          <p:cNvPicPr>
-            <a:picLocks noGrp="1" noChangeAspect="1"/>
-          </p:cNvPicPr>
-          <p:nvPr/>
-        </p:nvPicPr>
-        <p:blipFill>
-          <a:blip r:embed="rId2"/>
-          <a:stretch>
-            <a:fillRect/>
-          </a:stretch>
-        </p:blipFill>
-        <p:spPr bwMode="auto">
-          <a:xfrm>
-            <a:off x="127000" y="1765300"/>
-            <a:ext cx="4432300" cy="2324100"/>
-          </a:xfrm>
-          <a:prstGeom prst="rect">
-            <a:avLst/>
-          </a:prstGeom>
-          <a:noFill/>
-          <a:ln w="9525">
-            <a:noFill/>
-            <a:headEnd/>
-            <a:tailEnd/>
-          </a:ln>
-        </p:spPr>
-      </p:pic>
       <p:sp>
         <p:nvSpPr>
           <p:cNvPr id="5" name="Text Placeholder 4"/>
@@ -11918,306 +12133,331 @@
           <a:bodyPr/>
           <a:lstStyle/>
           <a:p>
-            <a:pPr lvl="0" indent="0">
-              <a:buNone/>
-            </a:pPr>
-            <a:r>
-              <a:rPr>
-                <a:solidFill>
-                  <a:srgbClr val="5E5E5E"/>
-                </a:solidFill>
-                <a:latin typeface="Courier"/>
-              </a:rPr>
-              <a:t># Mean predicted area per side ------------------------</a:t>
-            </a:r>
-            <a:br/>
-            <a:r>
-              <a:rPr>
-                <a:solidFill>
-                  <a:srgbClr val="003B4F"/>
-                </a:solidFill>
-                <a:latin typeface="Courier"/>
-              </a:rPr>
-              <a:t>leaf_df </a:t>
-            </a:r>
-            <a:r>
-              <a:rPr>
-                <a:solidFill>
-                  <a:srgbClr val="5E5E5E"/>
-                </a:solidFill>
-                <a:latin typeface="Courier"/>
-              </a:rPr>
-              <a:t>%&gt;%</a:t>
-            </a:r>
-            <a:br/>
-            <a:r>
-              <a:rPr>
-                <a:solidFill>
-                  <a:srgbClr val="003B4F"/>
-                </a:solidFill>
-                <a:latin typeface="Courier"/>
-              </a:rPr>
-              <a:t>  </a:t>
-            </a:r>
-            <a:r>
-              <a:rPr>
-                <a:solidFill>
-                  <a:srgbClr val="4758AB"/>
-                </a:solidFill>
-                <a:latin typeface="Courier"/>
-              </a:rPr>
-              <a:t>group_by</a:t>
-            </a:r>
-            <a:r>
-              <a:rPr>
-                <a:solidFill>
-                  <a:srgbClr val="003B4F"/>
-                </a:solidFill>
-                <a:latin typeface="Courier"/>
-              </a:rPr>
-              <a:t>(shade) </a:t>
-            </a:r>
-            <a:r>
-              <a:rPr>
-                <a:solidFill>
-                  <a:srgbClr val="5E5E5E"/>
-                </a:solidFill>
-                <a:latin typeface="Courier"/>
-              </a:rPr>
-              <a:t>%&gt;%</a:t>
-            </a:r>
-            <a:br/>
-            <a:r>
-              <a:rPr>
-                <a:solidFill>
-                  <a:srgbClr val="003B4F"/>
-                </a:solidFill>
-                <a:latin typeface="Courier"/>
-              </a:rPr>
-              <a:t>  </a:t>
-            </a:r>
-            <a:r>
-              <a:rPr>
-                <a:solidFill>
-                  <a:srgbClr val="4758AB"/>
-                </a:solidFill>
-                <a:latin typeface="Courier"/>
-              </a:rPr>
-              <a:t>summarize</a:t>
-            </a:r>
-            <a:r>
-              <a:rPr>
-                <a:solidFill>
-                  <a:srgbClr val="003B4F"/>
-                </a:solidFill>
-                <a:latin typeface="Courier"/>
-              </a:rPr>
-              <a:t>(</a:t>
-            </a:r>
-            <a:br/>
-            <a:r>
-              <a:rPr>
-                <a:solidFill>
-                  <a:srgbClr val="003B4F"/>
-                </a:solidFill>
-                <a:latin typeface="Courier"/>
-              </a:rPr>
-              <a:t>    </a:t>
-            </a:r>
-            <a:r>
-              <a:rPr>
-                <a:solidFill>
-                  <a:srgbClr val="657422"/>
-                </a:solidFill>
-                <a:latin typeface="Courier"/>
-              </a:rPr>
-              <a:t>n =</a:t>
-            </a:r>
-            <a:r>
-              <a:rPr>
-                <a:solidFill>
-                  <a:srgbClr val="003B4F"/>
-                </a:solidFill>
-                <a:latin typeface="Courier"/>
-              </a:rPr>
-              <a:t> </a:t>
-            </a:r>
-            <a:r>
-              <a:rPr>
-                <a:solidFill>
-                  <a:srgbClr val="4758AB"/>
-                </a:solidFill>
-                <a:latin typeface="Courier"/>
-              </a:rPr>
-              <a:t>sum</a:t>
-            </a:r>
-            <a:r>
-              <a:rPr>
-                <a:solidFill>
-                  <a:srgbClr val="003B4F"/>
-                </a:solidFill>
-                <a:latin typeface="Courier"/>
-              </a:rPr>
-              <a:t>(</a:t>
-            </a:r>
-            <a:r>
-              <a:rPr>
-                <a:solidFill>
-                  <a:srgbClr val="5E5E5E"/>
-                </a:solidFill>
-                <a:latin typeface="Courier"/>
-              </a:rPr>
-              <a:t>!</a:t>
-            </a:r>
-            <a:r>
-              <a:rPr>
-                <a:solidFill>
-                  <a:srgbClr val="4758AB"/>
-                </a:solidFill>
-                <a:latin typeface="Courier"/>
-              </a:rPr>
-              <a:t>is.na</a:t>
-            </a:r>
-            <a:r>
-              <a:rPr>
-                <a:solidFill>
-                  <a:srgbClr val="003B4F"/>
-                </a:solidFill>
-                <a:latin typeface="Courier"/>
-              </a:rPr>
-              <a:t>(leaf_area_cm2)),</a:t>
-            </a:r>
-            <a:br/>
-            <a:r>
-              <a:rPr>
-                <a:solidFill>
-                  <a:srgbClr val="003B4F"/>
-                </a:solidFill>
-                <a:latin typeface="Courier"/>
-              </a:rPr>
-              <a:t>    </a:t>
-            </a:r>
-            <a:r>
-              <a:rPr>
-                <a:solidFill>
-                  <a:srgbClr val="657422"/>
-                </a:solidFill>
-                <a:latin typeface="Courier"/>
-              </a:rPr>
-              <a:t>mean_area =</a:t>
-            </a:r>
-            <a:r>
-              <a:rPr>
-                <a:solidFill>
-                  <a:srgbClr val="003B4F"/>
-                </a:solidFill>
-                <a:latin typeface="Courier"/>
-              </a:rPr>
-              <a:t> </a:t>
-            </a:r>
-            <a:r>
-              <a:rPr>
-                <a:solidFill>
-                  <a:srgbClr val="4758AB"/>
-                </a:solidFill>
-                <a:latin typeface="Courier"/>
-              </a:rPr>
-              <a:t>mean</a:t>
-            </a:r>
-            <a:r>
-              <a:rPr>
-                <a:solidFill>
-                  <a:srgbClr val="003B4F"/>
-                </a:solidFill>
-                <a:latin typeface="Courier"/>
-              </a:rPr>
-              <a:t>(leaf_area_cm2, </a:t>
-            </a:r>
-            <a:r>
-              <a:rPr>
-                <a:solidFill>
-                  <a:srgbClr val="657422"/>
-                </a:solidFill>
-                <a:latin typeface="Courier"/>
-              </a:rPr>
-              <a:t>na.rm =</a:t>
-            </a:r>
-            <a:r>
-              <a:rPr>
-                <a:solidFill>
-                  <a:srgbClr val="003B4F"/>
-                </a:solidFill>
-                <a:latin typeface="Courier"/>
-              </a:rPr>
-              <a:t> </a:t>
-            </a:r>
-            <a:r>
-              <a:rPr>
-                <a:solidFill>
-                  <a:srgbClr val="8F5902"/>
-                </a:solidFill>
-                <a:latin typeface="Courier"/>
-              </a:rPr>
-              <a:t>TRUE</a:t>
-            </a:r>
-            <a:r>
-              <a:rPr>
-                <a:solidFill>
-                  <a:srgbClr val="003B4F"/>
-                </a:solidFill>
-                <a:latin typeface="Courier"/>
-              </a:rPr>
-              <a:t>)</a:t>
-            </a:r>
-            <a:br/>
-            <a:r>
-              <a:rPr>
-                <a:solidFill>
-                  <a:srgbClr val="003B4F"/>
-                </a:solidFill>
-                <a:latin typeface="Courier"/>
-              </a:rPr>
-              <a:t>  )</a:t>
-            </a:r>
-          </a:p>
-          <a:p>
-            <a:pPr lvl="0" indent="0">
-              <a:buNone/>
-            </a:pPr>
-            <a:r>
-              <a:rPr>
-                <a:latin typeface="Courier"/>
-              </a:rPr>
-              <a:t># A tibble: 2 × 3
-  shade     n mean_area
-  &lt;chr&gt; &lt;int&gt;     &lt;dbl&gt;
-1 shady    21      36.7
-2 sunny    19      36.0</a:t>
-            </a:r>
-          </a:p>
-          <a:p>
             <a:pPr lvl="0" indent="0" marL="0">
               <a:buNone/>
             </a:pPr>
             <a:r>
               <a:rPr/>
-              <a:t>About </a:t>
+              <a:t>Each team measured </a:t>
             </a:r>
             <a:r>
               <a:rPr b="1"/>
-              <a:t>37 cm²</a:t>
-            </a:r>
-            <a:r>
-              <a:rPr/>
-              <a:t> on the shady side and </a:t>
+              <a:t>both</a:t>
+            </a:r>
+            <a:r>
+              <a:rPr/>
+              <a:t> sides, so the team is the </a:t>
             </a:r>
             <a:r>
               <a:rPr b="1"/>
-              <a:t>36 cm²</a:t>
-            </a:r>
-            <a:r>
-              <a:rPr/>
-              <a:t> on the sunny side — the same story the t-test told us about mass, now in the units we actually wanted.</a:t>
+              <a:t>pair</a:t>
+            </a:r>
+            <a:r>
+              <a:rPr/>
+              <a:t>.</a:t>
+            </a:r>
+          </a:p>
+        </p:txBody>
+      </p:sp>
+      <p:graphicFrame>
+        <p:nvGraphicFramePr>
+          <p:cNvPr id="6" name="Content Placeholder 5"/>
+          <p:cNvGraphicFramePr>
+            <a:graphicFrameLocks noGrp="1"/>
+          </p:cNvGraphicFramePr>
+          <p:nvPr>
+            <p:ph idx="1"/>
+          </p:nvPr>
+        </p:nvGraphicFramePr>
+        <p:xfrm>
+          <a:off x="4749800" y="1295400"/>
+          <a:ext cx="4038600" cy="3276600"/>
+        </p:xfrm>
+        <a:graphic>
+          <a:graphicData uri="http://schemas.openxmlformats.org/drawingml/2006/table">
+            <a:tbl>
+              <a:tblPr firstRow="1" bandRow="1">
+                <a:tableStyleId>{5C22544A-7EE6-4342-B048-85BDC9FD1C3A}</a:tableStyleId>
+              </a:tblPr>
+              <a:tblGrid>
+                <a:gridCol w="800100"/>
+                <a:gridCol w="800100"/>
+                <a:gridCol w="800100"/>
+                <a:gridCol w="800100"/>
+                <a:gridCol w="800100"/>
+              </a:tblGrid>
+              <a:tr h="0">
+                <a:tc>
+                  <a:txBody>
+                    <a:bodyPr/>
+                    <a:lstStyle/>
+                    <a:p>
+                      <a:endParaRPr/>
+                    </a:p>
+                  </a:txBody>
+                  <a:tcPr/>
+                </a:tc>
+                <a:tc>
+                  <a:txBody>
+                    <a:bodyPr/>
+                    <a:lstStyle/>
+                    <a:p>
+                      <a:pPr lvl="0" indent="0" marL="0">
+                        <a:buNone/>
+                      </a:pPr>
+                      <a:r>
+                        <a:rPr/>
+                        <a:t>mean diff</a:t>
+                      </a:r>
+                    </a:p>
+                  </a:txBody>
+                  <a:tcPr/>
+                </a:tc>
+                <a:tc>
+                  <a:txBody>
+                    <a:bodyPr/>
+                    <a:lstStyle/>
+                    <a:p>
+                      <a:pPr lvl="0" indent="0" marL="0">
+                        <a:buNone/>
+                      </a:pPr>
+                      <a:r>
+                        <a:rPr i="1"/>
+                        <a:t>t</a:t>
+                      </a:r>
+                    </a:p>
+                  </a:txBody>
+                  <a:tcPr/>
+                </a:tc>
+                <a:tc>
+                  <a:txBody>
+                    <a:bodyPr/>
+                    <a:lstStyle/>
+                    <a:p>
+                      <a:pPr lvl="0" indent="0" marL="0">
+                        <a:buNone/>
+                      </a:pPr>
+                      <a:r>
+                        <a:rPr/>
+                        <a:t>df</a:t>
+                      </a:r>
+                    </a:p>
+                  </a:txBody>
+                  <a:tcPr/>
+                </a:tc>
+                <a:tc>
+                  <a:txBody>
+                    <a:bodyPr/>
+                    <a:lstStyle/>
+                    <a:p>
+                      <a:pPr lvl="0" indent="0" marL="0">
+                        <a:buNone/>
+                      </a:pPr>
+                      <a:r>
+                        <a:rPr i="1"/>
+                        <a:t>p</a:t>
+                      </a:r>
+                    </a:p>
+                  </a:txBody>
+                  <a:tcPr/>
+                </a:tc>
+              </a:tr>
+              <a:tr h="0">
+                <a:tc>
+                  <a:txBody>
+                    <a:bodyPr/>
+                    <a:lstStyle/>
+                    <a:p>
+                      <a:pPr lvl="0" indent="0" marL="0">
+                        <a:buNone/>
+                      </a:pPr>
+                      <a:r>
+                        <a:rPr/>
+                        <a:t>area</a:t>
+                      </a:r>
+                    </a:p>
+                  </a:txBody>
+                </a:tc>
+                <a:tc>
+                  <a:txBody>
+                    <a:bodyPr/>
+                    <a:lstStyle/>
+                    <a:p>
+                      <a:pPr lvl="0" indent="0" marL="0">
+                        <a:buNone/>
+                      </a:pPr>
+                      <a:r>
+                        <a:rPr/>
+                        <a:t>−1.2 cm²</a:t>
+                      </a:r>
+                    </a:p>
+                  </a:txBody>
+                </a:tc>
+                <a:tc>
+                  <a:txBody>
+                    <a:bodyPr/>
+                    <a:lstStyle/>
+                    <a:p>
+                      <a:pPr lvl="0" indent="0" marL="0">
+                        <a:buNone/>
+                      </a:pPr>
+                      <a:r>
+                        <a:rPr/>
+                        <a:t>−0.34</a:t>
+                      </a:r>
+                    </a:p>
+                  </a:txBody>
+                </a:tc>
+                <a:tc>
+                  <a:txBody>
+                    <a:bodyPr/>
+                    <a:lstStyle/>
+                    <a:p>
+                      <a:pPr lvl="0" indent="0" marL="0">
+                        <a:buNone/>
+                      </a:pPr>
+                      <a:r>
+                        <a:rPr/>
+                        <a:t>3</a:t>
+                      </a:r>
+                    </a:p>
+                  </a:txBody>
+                </a:tc>
+                <a:tc>
+                  <a:txBody>
+                    <a:bodyPr/>
+                    <a:lstStyle/>
+                    <a:p>
+                      <a:pPr lvl="0" indent="0" marL="0">
+                        <a:buNone/>
+                      </a:pPr>
+                      <a:r>
+                        <a:rPr/>
+                        <a:t>0.76</a:t>
+                      </a:r>
+                    </a:p>
+                  </a:txBody>
+                </a:tc>
+              </a:tr>
+              <a:tr h="0">
+                <a:tc>
+                  <a:txBody>
+                    <a:bodyPr/>
+                    <a:lstStyle/>
+                    <a:p>
+                      <a:pPr lvl="0" indent="0" marL="0">
+                        <a:buNone/>
+                      </a:pPr>
+                      <a:r>
+                        <a:rPr/>
+                        <a:t>mass</a:t>
+                      </a:r>
+                    </a:p>
+                  </a:txBody>
+                </a:tc>
+                <a:tc>
+                  <a:txBody>
+                    <a:bodyPr/>
+                    <a:lstStyle/>
+                    <a:p>
+                      <a:pPr lvl="0" indent="0" marL="0">
+                        <a:buNone/>
+                      </a:pPr>
+                      <a:r>
+                        <a:rPr/>
+                        <a:t>−0.016 g</a:t>
+                      </a:r>
+                    </a:p>
+                  </a:txBody>
+                </a:tc>
+                <a:tc>
+                  <a:txBody>
+                    <a:bodyPr/>
+                    <a:lstStyle/>
+                    <a:p>
+                      <a:pPr lvl="0" indent="0" marL="0">
+                        <a:buNone/>
+                      </a:pPr>
+                      <a:r>
+                        <a:rPr/>
+                        <a:t>−0.25</a:t>
+                      </a:r>
+                    </a:p>
+                  </a:txBody>
+                </a:tc>
+                <a:tc>
+                  <a:txBody>
+                    <a:bodyPr/>
+                    <a:lstStyle/>
+                    <a:p>
+                      <a:pPr lvl="0" indent="0" marL="0">
+                        <a:buNone/>
+                      </a:pPr>
+                      <a:r>
+                        <a:rPr/>
+                        <a:t>4</a:t>
+                      </a:r>
+                    </a:p>
+                  </a:txBody>
+                </a:tc>
+                <a:tc>
+                  <a:txBody>
+                    <a:bodyPr/>
+                    <a:lstStyle/>
+                    <a:p>
+                      <a:pPr lvl="0" indent="0" marL="0">
+                        <a:buNone/>
+                      </a:pPr>
+                      <a:r>
+                        <a:rPr/>
+                        <a:t>0.81</a:t>
+                      </a:r>
+                    </a:p>
+                  </a:txBody>
+                </a:tc>
+              </a:tr>
+            </a:tbl>
+          </a:graphicData>
+        </a:graphic>
+      </p:graphicFrame>
+      <p:sp>
+        <p:nvSpPr>
+          <p:cNvPr id="6" name="Content Placeholder 5"/>
+          <p:cNvSpPr>
+            <a:spLocks noGrp="1"/>
+          </p:cNvSpPr>
+          <p:nvPr>
+            <p:ph idx="4" sz="quarter"/>
+          </p:nvPr>
+        </p:nvSpPr>
+        <p:spPr/>
+        <p:txBody>
+          <a:bodyPr/>
+          <a:lstStyle/>
+          <a:p>
+            <a:pPr lvl="0"/>
+            <a:r>
+              <a:rPr b="1"/>
+              <a:t>Neither is significant</a:t>
+            </a:r>
+            <a:r>
+              <a:rPr/>
+              <a:t> — with 5 teams there is not much power</a:t>
+            </a:r>
+          </a:p>
+          <a:p>
+            <a:pPr lvl="0"/>
+            <a:r>
+              <a:rPr/>
+              <a:t>The </a:t>
+            </a:r>
+            <a:r>
+              <a:rPr b="1"/>
+              <a:t>area</a:t>
+            </a:r>
+            <a:r>
+              <a:rPr/>
+              <a:t> test has df = 3: one team never traced their leaves</a:t>
             </a:r>
           </a:p>
           <a:p>
@@ -12234,12 +12474,8 @@
               <a:buNone/>
             </a:pPr>
             <a:r>
-              <a:rPr sz="2000" b="1"/>
-              <a:t>✅ Why this matters.</a:t>
-            </a:r>
-            <a:r>
               <a:rPr sz="2000"/>
-              <a:t> “Shady leaves weigh 0.02 g more” means little to a reader. “Shady leaves are about 1 cm² bigger” is a sentence an ecologist can use.</a:t>
+              <a:t>A real answer of “we could not detect a difference” is still an answer.</a:t>
             </a:r>
           </a:p>
         </p:txBody>
@@ -12353,7 +12589,7 @@
             </a:pPr>
             <a:r>
               <a:rPr sz="2000" i="1"/>
-              <a:t>Paper mass was a very strong predictor of paper area (linear regression: F(1, 116) = 784,900, p &lt; 0.001, R² = 0.9999). The calibration equation was area = 0.28 + 130.52 × mass. Residual scatter increased with square size, so intervals for the largest squares should be treated with caution.</a:t>
+              <a:t>Paper area was a very strong predictor of paper mass (linear regression: F(1, 116) = 784,900, p &lt; 0.001, R² = 0.9999). The calibration equation was mass = −0.0021 + 0.00766 × area, equivalent to 76.6 g/m². Residual scatter increased with square size, so the largest squares are the least well described.</a:t>
             </a:r>
           </a:p>
         </p:txBody>
@@ -12627,7 +12863,7 @@
                         <a:rPr>
                           <a:latin typeface="Courier"/>
                         </a:rPr>
-                        <a:t>mass_g</a:t>
+                        <a:t>area_cm2</a:t>
                       </a:r>
                       <a:r>
                         <a:rPr/>
@@ -12748,7 +12984,7 @@
             </a:pPr>
             <a:r>
               <a:rPr/>
-              <a:t>→ ACTIVITY 11 Parts 5–9 now</a:t>
+              <a:t>→ ACTIVITY 11 Parts 4–7 now</a:t>
             </a:r>
           </a:p>
         </p:txBody>
@@ -12773,14 +13009,14 @@
             </a:pPr>
             <a:r>
               <a:rPr b="1"/>
-              <a:t>🛑 Do Activity Parts 5–9 now</a:t>
+              <a:t>🛑 Do Activity Parts 4–7 now</a:t>
             </a:r>
           </a:p>
           <a:p>
             <a:pPr lvl="0"/>
             <a:r>
               <a:rPr/>
-              <a:t>Draw the line and run </a:t>
+              <a:t>Run </a:t>
             </a:r>
             <a:r>
               <a:rPr>
@@ -12788,12 +13024,16 @@
               </a:rPr>
               <a:t>plot(model)</a:t>
             </a:r>
+            <a:r>
+              <a:rPr/>
+              <a:t> and say whether the assumptions are met</a:t>
+            </a:r>
           </a:p>
           <a:p>
             <a:pPr lvl="0"/>
             <a:r>
               <a:rPr/>
-              <a:t>Predict one tracing, then convert the whole </a:t>
+              <a:t>Convert the whole </a:t>
             </a:r>
             <a:r>
               <a:rPr>
@@ -12810,7 +13050,15 @@
             <a:pPr lvl="0"/>
             <a:r>
               <a:rPr/>
-              <a:t>Write your results sentence</a:t>
+              <a:t>Average to one value per team per side, then run both paired </a:t>
+            </a:r>
+            <a:r>
+              <a:rPr i="1"/>
+              <a:t>t</a:t>
+            </a:r>
+            <a:r>
+              <a:rPr/>
+              <a:t>-tests</a:t>
             </a:r>
           </a:p>
           <a:p>
@@ -12821,7 +13069,7 @@
             </a:r>
             <a:r>
               <a:rPr b="1"/>
-              <a:t>answers</a:t>
+              <a:t>four answers</a:t>
             </a:r>
             <a:r>
               <a:rPr/>
@@ -13095,11 +13343,11 @@
                   <a:rPr>
                     <a:latin typeface="Courier"/>
                   </a:rPr>
-                  <a:t>predict(model, newdata = ...)</a:t>
+                  <a:t>7.660e-03</a:t>
                 </a:r>
                 <a:r>
                   <a:rPr/>
-                  <a:t> — use it</a:t>
+                  <a:t> = 0.007660 — reading scientific notation</a:t>
                 </a:r>
               </a:p>
             </p:txBody>

</xml_diff>